<commit_message>
chore(learn): 更新 loop-engineering 分享 PPT
</commit_message>
<xml_diff>
--- a/topics/loop-engineering/share/slides.pptx
+++ b/topics/loop-engineering/share/slides.pptx
@@ -4,6 +4,9 @@
   <p:sldMasterIdLst>
     <p:sldMasterId id="2147483648" r:id="rId1"/>
   </p:sldMasterIdLst>
+  <p:notesMasterIdLst>
+    <p:notesMasterId r:id="rId17"/>
+  </p:notesMasterIdLst>
   <p:sldIdLst>
     <p:sldId id="256" r:id="rId2"/>
     <p:sldId id="257" r:id="rId3"/>
@@ -21,11 +24,8 @@
     <p:sldId id="269" r:id="rId15"/>
     <p:sldId id="270" r:id="rId16"/>
   </p:sldIdLst>
-  <p:notesMasterIdLst>
-    <p:notesMasterId r:id="rId17"/>
-  </p:notesMasterIdLst>
-  <p:sldSz cx="12188952" cy="6858000"/>
-  <p:notesSz cx="6858000" cy="12188952"/>
+  <p:sldSz cx="12188825" cy="6858000"/>
+  <p:notesSz cx="6858000" cy="12188825"/>
   <p:defaultTextStyle>
     <a:lvl1pPr marL="0" algn="l" defTabSz="914400" rtl="0" eaLnBrk="1" latinLnBrk="0" hangingPunct="1">
       <a:defRPr sz="1800" kern="1200">
@@ -118,6 +118,11 @@
       </a:defRPr>
     </a:lvl9pPr>
   </p:defaultTextStyle>
+  <p:extLst>
+    <p:ext uri="{EFAFB233-063F-42B5-8137-9DF3F51BA10A}">
+      <p15:sldGuideLst xmlns:p15="http://schemas.microsoft.com/office/powerpoint/2012/main"/>
+    </p:ext>
+  </p:extLst>
 </p:presentation>
 </file>
 
@@ -143,234 +148,10 @@
           <a:chExt cx="0" cy="0"/>
         </a:xfrm>
       </p:grpSpPr>
-      <p:sp>
-        <p:nvSpPr>
-          <p:cNvPr id="2" name="Header Placeholder 1"/>
-          <p:cNvSpPr>
-            <a:spLocks noGrp="1"/>
-          </p:cNvSpPr>
-          <p:nvPr>
-            <p:ph type="hdr" sz="quarter"/>
-          </p:nvPr>
-        </p:nvSpPr>
-        <p:spPr>
-          <a:xfrm>
-            <a:off x="0" y="0"/>
-            <a:ext cx="2971800" cy="458788"/>
-          </a:xfrm>
-          <a:prstGeom prst="rect">
-            <a:avLst/>
-          </a:prstGeom>
-        </p:spPr>
-        <p:txBody>
-          <a:bodyPr vert="horz" lIns="91440" tIns="45720" rIns="91440" bIns="45720" rtlCol="0"/>
-          <a:lstStyle>
-            <a:lvl1pPr algn="l">
-              <a:defRPr sz="1200"/>
-            </a:lvl1pPr>
-          </a:lstStyle>
-          <a:p>
-            <a:endParaRPr lang="en-US"/>
-          </a:p>
-        </p:txBody>
-      </p:sp>
-      <p:sp>
-        <p:nvSpPr>
-          <p:cNvPr id="3" name="Date Placeholder 2"/>
-          <p:cNvSpPr>
-            <a:spLocks noGrp="1"/>
-          </p:cNvSpPr>
-          <p:nvPr>
-            <p:ph type="dt" idx="1"/>
-          </p:nvPr>
-        </p:nvSpPr>
-        <p:spPr>
-          <a:xfrm>
-            <a:off x="3884613" y="0"/>
-            <a:ext cx="2971800" cy="458788"/>
-          </a:xfrm>
-          <a:prstGeom prst="rect">
-            <a:avLst/>
-          </a:prstGeom>
-        </p:spPr>
-        <p:txBody>
-          <a:bodyPr vert="horz" lIns="91440" tIns="45720" rIns="91440" bIns="45720" rtlCol="0"/>
-          <a:lstStyle>
-            <a:lvl1pPr algn="r">
-              <a:defRPr sz="1200"/>
-            </a:lvl1pPr>
-          </a:lstStyle>
-          <a:p>
-            <a:fld id="{5282F153-3F37-0F45-9E97-73ACFA13230C}" type="datetimeFigureOut">
-              <a:rPr lang="en-US"/>
-              <a:t>7/23/19</a:t>
-            </a:fld>
-            <a:endParaRPr lang="en-US"/>
-          </a:p>
-        </p:txBody>
-      </p:sp>
-      <p:sp>
-        <p:nvSpPr>
-          <p:cNvPr id="4" name="Slide Image Placeholder 3"/>
-          <p:cNvSpPr>
-            <a:spLocks noGrp="1" noRot="1" noChangeAspect="1"/>
-          </p:cNvSpPr>
-          <p:nvPr>
-            <p:ph type="sldImg" idx="2"/>
-          </p:nvPr>
-        </p:nvSpPr>
-        <p:spPr>
-          <a:xfrm>
-            <a:off x="685800" y="1143000"/>
-            <a:ext cx="5486400" cy="3086100"/>
-          </a:xfrm>
-          <a:prstGeom prst="rect">
-            <a:avLst/>
-          </a:prstGeom>
-          <a:noFill/>
-          <a:ln w="12700">
-            <a:solidFill>
-              <a:prstClr val="black"/>
-            </a:solidFill>
-          </a:ln>
-        </p:spPr>
-        <p:txBody>
-          <a:bodyPr vert="horz" lIns="91440" tIns="45720" rIns="91440" bIns="45720" rtlCol="0" anchor="ctr"/>
-          <a:lstStyle/>
-          <a:p>
-            <a:endParaRPr lang="en-US"/>
-          </a:p>
-        </p:txBody>
-      </p:sp>
-      <p:sp>
-        <p:nvSpPr>
-          <p:cNvPr id="5" name="Notes Placeholder 4"/>
-          <p:cNvSpPr>
-            <a:spLocks noGrp="1"/>
-          </p:cNvSpPr>
-          <p:nvPr>
-            <p:ph type="body" sz="quarter" idx="3"/>
-          </p:nvPr>
-        </p:nvSpPr>
-        <p:spPr>
-          <a:xfrm>
-            <a:off x="685800" y="4400550"/>
-            <a:ext cx="5486400" cy="3600450"/>
-          </a:xfrm>
-          <a:prstGeom prst="rect">
-            <a:avLst/>
-          </a:prstGeom>
-        </p:spPr>
-        <p:txBody>
-          <a:bodyPr vert="horz" lIns="91440" tIns="45720" rIns="91440" bIns="45720" rtlCol="0"/>
-          <a:lstStyle/>
-          <a:p>
-            <a:pPr lvl="0"/>
-            <a:r>
-              <a:rPr lang="en-US"/>
-              <a:t>Click to edit Master text styles</a:t>
-            </a:r>
-          </a:p>
-          <a:p>
-            <a:pPr lvl="1"/>
-            <a:r>
-              <a:rPr lang="en-US"/>
-              <a:t>Second level</a:t>
-            </a:r>
-          </a:p>
-          <a:p>
-            <a:pPr lvl="2"/>
-            <a:r>
-              <a:rPr lang="en-US"/>
-              <a:t>Third level</a:t>
-            </a:r>
-          </a:p>
-          <a:p>
-            <a:pPr lvl="3"/>
-            <a:r>
-              <a:rPr lang="en-US"/>
-              <a:t>Fourth level</a:t>
-            </a:r>
-          </a:p>
-          <a:p>
-            <a:pPr lvl="4"/>
-            <a:r>
-              <a:rPr lang="en-US"/>
-              <a:t>Fifth level</a:t>
-            </a:r>
-          </a:p>
-        </p:txBody>
-      </p:sp>
-      <p:sp>
-        <p:nvSpPr>
-          <p:cNvPr id="6" name="Footer Placeholder 5"/>
-          <p:cNvSpPr>
-            <a:spLocks noGrp="1"/>
-          </p:cNvSpPr>
-          <p:nvPr>
-            <p:ph type="ftr" sz="quarter" idx="4"/>
-          </p:nvPr>
-        </p:nvSpPr>
-        <p:spPr>
-          <a:xfrm>
-            <a:off x="0" y="8685213"/>
-            <a:ext cx="2971800" cy="458787"/>
-          </a:xfrm>
-          <a:prstGeom prst="rect">
-            <a:avLst/>
-          </a:prstGeom>
-        </p:spPr>
-        <p:txBody>
-          <a:bodyPr vert="horz" lIns="91440" tIns="45720" rIns="91440" bIns="45720" rtlCol="0" anchor="b"/>
-          <a:lstStyle>
-            <a:lvl1pPr algn="l">
-              <a:defRPr sz="1200"/>
-            </a:lvl1pPr>
-          </a:lstStyle>
-          <a:p>
-            <a:endParaRPr lang="en-US"/>
-          </a:p>
-        </p:txBody>
-      </p:sp>
-      <p:sp>
-        <p:nvSpPr>
-          <p:cNvPr id="7" name="Slide Number Placeholder 6"/>
-          <p:cNvSpPr>
-            <a:spLocks noGrp="1"/>
-          </p:cNvSpPr>
-          <p:nvPr>
-            <p:ph type="sldNum" sz="quarter" idx="5"/>
-          </p:nvPr>
-        </p:nvSpPr>
-        <p:spPr>
-          <a:xfrm>
-            <a:off x="3884613" y="8685213"/>
-            <a:ext cx="2971800" cy="458787"/>
-          </a:xfrm>
-          <a:prstGeom prst="rect">
-            <a:avLst/>
-          </a:prstGeom>
-        </p:spPr>
-        <p:txBody>
-          <a:bodyPr vert="horz" lIns="91440" tIns="45720" rIns="91440" bIns="45720" rtlCol="0" anchor="b"/>
-          <a:lstStyle>
-            <a:lvl1pPr algn="r">
-              <a:defRPr sz="1200"/>
-            </a:lvl1pPr>
-          </a:lstStyle>
-          <a:p>
-            <a:fld id="{CE5E9CC1-C706-0F49-92D6-E571CC5EEA8F}" type="slidenum">
-              <a:rPr lang="en-US"/>
-              <a:t>‹#›</a:t>
-            </a:fld>
-            <a:endParaRPr lang="en-US"/>
-          </a:p>
-        </p:txBody>
-      </p:sp>
     </p:spTree>
     <p:extLst>
       <p:ext uri="{BB962C8B-B14F-4D97-AF65-F5344CB8AC3E}">
-        <p14:creationId xmlns:p14="http://schemas.microsoft.com/office/powerpoint/2010/main" val="1024086991"/>
+        <p14:creationId xmlns:p14="http://schemas.microsoft.com/office/powerpoint/2010/main" val="2501181034"/>
       </p:ext>
     </p:extLst>
   </p:cSld>
@@ -518,7 +299,6 @@
               <a:rPr lang="en-US" dirty="0"/>
               <a:t>开场：今天讲一个非常新的话题——新到这个词是 2026 年 6 月 7 日才出现的。但内容不玄：你们每天用 Claude Code/Codex 时已经身处其中。今天的目标是给大家一套看清这类工具的框架，以及它正在怎么改变我们的工作方式。</a:t>
             </a:r>
-            <a:endParaRPr lang="en-US" dirty="0"/>
           </a:p>
         </p:txBody>
       </p:sp>
@@ -606,7 +386,6 @@
               <a:rPr lang="en-US" dirty="0"/>
               <a:t>重点讲空转（标⚠的）：它比死循环危险，因为监控上『看起来在干活』——每轮都有新工具调用、新产出、日志各不相同，只有对比多轮状态才发现进度没动。发现晚 = 烧得多。死循环反而显形（重复日志、轮数飙升）。这是我学习时亲自踩过的坑，大家直觉也容易反。</a:t>
             </a:r>
-            <a:endParaRPr lang="en-US" dirty="0"/>
           </a:p>
         </p:txBody>
       </p:sp>
@@ -694,7 +473,6 @@
               <a:rPr lang="en-US" dirty="0"/>
               <a:t>四支柱是互补不是冗余，逐个讲清各防哪种失败。可以现场出题考听众：『只装迭代上限行不行？』——不行，单轮开销大的场景它管不住（token 预算管），空转它要等到耗满才拦（无进展检测管）。</a:t>
             </a:r>
-            <a:endParaRPr lang="en-US" dirty="0"/>
           </a:p>
         </p:txBody>
       </p:sp>
@@ -782,7 +560,6 @@
               <a:rPr lang="en-US" dirty="0"/>
               <a:t>坦诚告诉听众这是我自己踩过的坑，效果比讲教科书好。误区②可以互动：先问『值班修 bug 这种标准任务，是不是就没有理解债务了？』——等有人点头再揭示。</a:t>
             </a:r>
-            <a:endParaRPr lang="en-US" dirty="0"/>
           </a:p>
         </p:txBody>
       </p:sp>
@@ -870,7 +647,6 @@
               <a:rPr lang="en-US" dirty="0"/>
               <a:t>收束到人。两个陷阱讲完后停顿，读底部那句原话。结束观点：loop engineering 不是让人退场，而是把人挪到唯一不可替代的位置——评判者-执行者分离原则的人类版：你是最外层的评判者。</a:t>
             </a:r>
-            <a:endParaRPr lang="en-US" dirty="0"/>
           </a:p>
         </p:txBody>
       </p:sp>
@@ -958,7 +734,6 @@
               <a:rPr lang="en-US" dirty="0"/>
               <a:t>行动建议落地：让每个人挑一个自己手头『重复 + 有标准 + 可验证』的任务，下周试着为它设计第一个 loop（哪怕只是 cron + 一个明确的完成条件 + 迭代上限）。强调第三列：验收不可省。</a:t>
             </a:r>
-            <a:endParaRPr lang="en-US" dirty="0"/>
           </a:p>
         </p:txBody>
       </p:sp>
@@ -1046,7 +821,6 @@
               <a:rPr lang="en-US" dirty="0"/>
               <a:t>这五个问题来自真实的费曼式追问演练，全部被问过。讲不完时间可以跳过本页，但被问到时直接翻过来。</a:t>
             </a:r>
-            <a:endParaRPr lang="en-US" dirty="0"/>
           </a:p>
         </p:txBody>
       </p:sp>
@@ -1134,7 +908,6 @@
               <a:rPr lang="en-US" dirty="0"/>
               <a:t>时间线讲清楚：循环这个机制 2022 年就有（ReAct），2023 年 AutoGPT 试过自动化但失败，2024-25 年工具成熟。真正的引爆点是今年 6 月 7 日 Steinberger 那条帖子。重点读 Cherny 的话——Claude Code 的创造者自己已经不手动提示了。提问预埋：有人会问『这是不是又一个炒概念』——回答：概念是新的，但它命名的是已经在顶级团队真实运转的工作方式。</a:t>
             </a:r>
-            <a:endParaRPr lang="en-US" dirty="0"/>
           </a:p>
         </p:txBody>
       </p:sp>
@@ -1222,7 +995,6 @@
               <a:rPr lang="en-US" dirty="0"/>
               <a:t>用听众熟悉的三个场景对比。关键句：能力来自循环而不只是模型——同一个模型，单次调用猜错就交卷，循环里错误变成下一轮的线索（测试报错恰恰是修对 bug 的依据）。把『判断刀』讲透：CI 自动重试 3 次不是 loop，因为重试策略是写死的。</a:t>
             </a:r>
-            <a:endParaRPr lang="en-US" dirty="0"/>
           </a:p>
         </p:txBody>
       </p:sp>
@@ -1310,7 +1082,6 @@
               <a:rPr lang="en-US" dirty="0"/>
               <a:t>这是全场最重要的一页概念区分（我自己学的时候就在这里卡过）：agentic loop 是『物』，loop engineering 是『造物和驾驭物的手艺』。强调：外循环现在就是各位本人——你坐在终端前决定下一条消息发什么，就是在人肉充当外循环。</a:t>
             </a:r>
-            <a:endParaRPr lang="en-US" dirty="0"/>
           </a:p>
         </p:txBody>
       </p:sp>
@@ -1398,7 +1169,6 @@
               <a:rPr lang="en-US" dirty="0"/>
               <a:t>强调可验证目标：这是新手最容易踩的第一个坑——给 loop 一个模糊目标（『优化到足够好』），它永远停不下来。提问预埋：『agent 中途停下来问人算不算失败？』——不算，那是它判断需要循环外部的输入，主动让出控制权，属于终止条件设计的一部分。</a:t>
             </a:r>
-            <a:endParaRPr lang="en-US" dirty="0"/>
           </a:p>
         </p:txBody>
       </p:sp>
@@ -1486,7 +1256,6 @@
               <a:rPr lang="en-US" dirty="0"/>
               <a:t>逐个点名，每个都问听众『你在 Claude Code 里见过它的哪个形态』。彩蛋：我学这个主题用的学习工作流，本身就是按这六大构件搭的——/learn 是技能、测验是验证分离、state.md 是状态管理。讲完可以现场展示仓库。</a:t>
             </a:r>
-            <a:endParaRPr lang="en-US" dirty="0"/>
           </a:p>
         </p:txBody>
       </p:sp>
@@ -1574,7 +1343,6 @@
               <a:rPr lang="en-US" dirty="0"/>
               <a:t>这是整套设计原则里最重要的一条。盲区共享要展开讲：不是 agent『偷懒』或『撒谎』，而是结构性问题——检查者与犯错者共享上下文，错误就检不出来。延伸：这个原则可以推广到组织层面——跨团队的 loop 协作，A 团队的产出由 B 团队的验证 loop 把关。</a:t>
             </a:r>
-            <a:endParaRPr lang="en-US" dirty="0"/>
           </a:p>
         </p:txBody>
       </p:sp>
@@ -1662,7 +1430,6 @@
               <a:rPr lang="en-US" dirty="0"/>
               <a:t>Osmani 原话：The agent forgets, the repo doesn't. 重点讲『失败尝试』——失败烧了真实的 token 和时间，不落盘等于把买来的教训扔掉。诊断案例：一个夜间循环连续三晚尝试同一个装不上的依赖——病因就是失败没落盘，每晚冷启动都重新『发现』同一个好主意。另外强调状态要人可读（markdown 而非数据库）：出问题时是人来审计。</a:t>
             </a:r>
-            <a:endParaRPr lang="en-US" dirty="0"/>
           </a:p>
         </p:txBody>
       </p:sp>
@@ -1750,7 +1517,6 @@
               <a:rPr lang="en-US" dirty="0"/>
               <a:t>这是我自己在结业考核里被追问出来的案例，照着讲就行。关键对比：以前你不在，它就停工；现在它夜里干活，你早晨只做验收。下面『认输机制』必讲——所有人都会问『修不好怎么办』：答案是跨 loop 协作（等依赖方信号）和无进展检测（降级给人），千万不要让它『直到修复为止』地跑下去。</a:t>
             </a:r>
-            <a:endParaRPr lang="en-US" dirty="0"/>
           </a:p>
         </p:txBody>
       </p:sp>
@@ -1823,6 +1589,11 @@
 <file path=ppt/slideMasters/slideMaster1.xml><?xml version="1.0" encoding="utf-8"?>
 <p:sldMaster xmlns:a="http://schemas.openxmlformats.org/drawingml/2006/main" xmlns:r="http://schemas.openxmlformats.org/officeDocument/2006/relationships" xmlns:p="http://schemas.openxmlformats.org/presentationml/2006/main">
   <p:cSld>
+    <p:bg>
+      <p:bgRef idx="1001">
+        <a:schemeClr val="bg1"/>
+      </p:bgRef>
+    </p:bg>
     <p:spTree>
       <p:nvGrpSpPr>
         <p:cNvPr id="1" name=""/>
@@ -2105,6 +1876,7 @@
         <a:solidFill>
           <a:srgbClr val="1E2761"/>
         </a:solidFill>
+        <a:effectLst/>
       </p:bgPr>
     </p:bg>
     <p:spTree>
@@ -2286,11 +2058,11 @@
           <a:bodyPr wrap="square" rtlCol="0" anchor="ctr"/>
           <a:lstStyle/>
           <a:p>
-            <a:pPr indent="0" marL="0">
-              <a:buNone/>
-            </a:pPr>
-            <a:r>
-              <a:rPr lang="en-US" sz="1500" b="1" spc="600" kern="0" dirty="0">
+            <a:pPr marL="0" indent="0">
+              <a:buNone/>
+            </a:pPr>
+            <a:r>
+              <a:rPr lang="en-US" sz="1500" b="1" kern="0" spc="600" dirty="0">
                 <a:solidFill>
                   <a:srgbClr val="CADCFC"/>
                 </a:solidFill>
@@ -2325,7 +2097,7 @@
           <a:bodyPr wrap="square" rtlCol="0" anchor="ctr"/>
           <a:lstStyle/>
           <a:p>
-            <a:pPr indent="0" marL="0">
+            <a:pPr marL="0" indent="0">
               <a:buNone/>
             </a:pPr>
             <a:r>
@@ -2364,7 +2136,7 @@
           <a:bodyPr wrap="square" rtlCol="0" anchor="ctr"/>
           <a:lstStyle/>
           <a:p>
-            <a:pPr indent="0" marL="0">
+            <a:pPr marL="0" indent="0">
               <a:buNone/>
             </a:pPr>
             <a:r>
@@ -2378,9 +2150,6 @@
               </a:rPr>
               <a:t>别再提示 agent 了，</a:t>
             </a:r>
-            <a:pPr indent="0" marL="0">
-              <a:buNone/>
-            </a:pPr>
             <a:r>
               <a:rPr lang="en-US" sz="2200" b="1" dirty="0">
                 <a:solidFill>
@@ -2417,7 +2186,7 @@
           <a:bodyPr wrap="square" rtlCol="0" anchor="ctr"/>
           <a:lstStyle/>
           <a:p>
-            <a:pPr indent="0" marL="0">
+            <a:pPr marL="0" indent="0">
               <a:buNone/>
             </a:pPr>
             <a:r>
@@ -2481,7 +2250,7 @@
           <a:bodyPr wrap="square" rtlCol="0" anchor="ctr"/>
           <a:lstStyle/>
           <a:p>
-            <a:pPr indent="0" marL="0">
+            <a:pPr marL="0" indent="0">
               <a:buNone/>
             </a:pPr>
             <a:r>
@@ -2515,6 +2284,7 @@
         <a:solidFill>
           <a:srgbClr val="FFFFFF"/>
         </a:solidFill>
+        <a:effectLst/>
       </p:bgPr>
     </p:bg>
     <p:spTree>
@@ -2552,11 +2322,11 @@
           <a:bodyPr wrap="square" rtlCol="0" anchor="ctr"/>
           <a:lstStyle/>
           <a:p>
-            <a:pPr indent="0" marL="0">
-              <a:buNone/>
-            </a:pPr>
-            <a:r>
-              <a:rPr lang="en-US" sz="1200" b="1" spc="200" kern="0" dirty="0">
+            <a:pPr marL="0" indent="0">
+              <a:buNone/>
+            </a:pPr>
+            <a:r>
+              <a:rPr lang="en-US" sz="1200" b="1" kern="0" spc="200" dirty="0">
                 <a:solidFill>
                   <a:srgbClr val="F96167"/>
                 </a:solidFill>
@@ -2591,7 +2361,7 @@
           <a:bodyPr wrap="square" rtlCol="0" anchor="ctr"/>
           <a:lstStyle/>
           <a:p>
-            <a:pPr indent="0" marL="0">
+            <a:pPr marL="0" indent="0">
               <a:buNone/>
             </a:pPr>
             <a:r>
@@ -2697,16 +2467,34 @@
         </p:nvGraphicFramePr>
         <p:xfrm>
           <a:off x="548640" y="1755648"/>
-          <a:ext cx="11091672" cy="914400"/>
+          <a:ext cx="11091672" cy="3511296"/>
         </p:xfrm>
         <a:graphic>
           <a:graphicData uri="http://schemas.openxmlformats.org/drawingml/2006/table">
             <a:tbl>
               <a:tblPr/>
               <a:tblGrid>
-                <a:gridCol w="2286000"/>
-                <a:gridCol w="4965192"/>
-                <a:gridCol w="3840480"/>
+                <a:gridCol w="2286000">
+                  <a:extLst>
+                    <a:ext uri="{9D8B030D-6E8A-4147-A177-3AD203B41FA5}">
+                      <a16:colId xmlns:a16="http://schemas.microsoft.com/office/drawing/2014/main" val="20000"/>
+                    </a:ext>
+                  </a:extLst>
+                </a:gridCol>
+                <a:gridCol w="4965192">
+                  <a:extLst>
+                    <a:ext uri="{9D8B030D-6E8A-4147-A177-3AD203B41FA5}">
+                      <a16:colId xmlns:a16="http://schemas.microsoft.com/office/drawing/2014/main" val="20001"/>
+                    </a:ext>
+                  </a:extLst>
+                </a:gridCol>
+                <a:gridCol w="3840480">
+                  <a:extLst>
+                    <a:ext uri="{9D8B030D-6E8A-4147-A177-3AD203B41FA5}">
+                      <a16:colId xmlns:a16="http://schemas.microsoft.com/office/drawing/2014/main" val="20002"/>
+                    </a:ext>
+                  </a:extLst>
+                </a:gridCol>
               </a:tblGrid>
               <a:tr h="585216">
                 <a:tc>
@@ -2714,7 +2502,7 @@
                     <a:bodyPr/>
                     <a:lstStyle/>
                     <a:p>
-                      <a:pPr indent="0" marL="0">
+                      <a:pPr marL="0" indent="0">
                         <a:buNone/>
                       </a:pPr>
                       <a:r>
@@ -2735,7 +2523,7 @@
                       </a:endParaRPr>
                     </a:p>
                   </a:txBody>
-                  <a:tcPr marL="91440" marR="91440" marT="45720" marB="45720" anchor="ctr">
+                  <a:tcPr anchor="ctr">
                     <a:lnL w="12700" cap="flat" cmpd="sng" algn="ctr">
                       <a:solidFill>
                         <a:srgbClr val="D8E2F5"/>
@@ -2782,7 +2570,7 @@
                     <a:bodyPr/>
                     <a:lstStyle/>
                     <a:p>
-                      <a:pPr indent="0" marL="0">
+                      <a:pPr marL="0" indent="0">
                         <a:buNone/>
                       </a:pPr>
                       <a:r>
@@ -2803,7 +2591,7 @@
                       </a:endParaRPr>
                     </a:p>
                   </a:txBody>
-                  <a:tcPr marL="91440" marR="91440" marT="45720" marB="45720" anchor="ctr">
+                  <a:tcPr anchor="ctr">
                     <a:lnL w="12700" cap="flat" cmpd="sng" algn="ctr">
                       <a:solidFill>
                         <a:srgbClr val="D8E2F5"/>
@@ -2850,7 +2638,7 @@
                     <a:bodyPr/>
                     <a:lstStyle/>
                     <a:p>
-                      <a:pPr indent="0" marL="0">
+                      <a:pPr marL="0" indent="0">
                         <a:buNone/>
                       </a:pPr>
                       <a:r>
@@ -2871,7 +2659,7 @@
                       </a:endParaRPr>
                     </a:p>
                   </a:txBody>
-                  <a:tcPr marL="91440" marR="91440" marT="45720" marB="45720" anchor="ctr">
+                  <a:tcPr anchor="ctr">
                     <a:lnL w="12700" cap="flat" cmpd="sng" algn="ctr">
                       <a:solidFill>
                         <a:srgbClr val="D8E2F5"/>
@@ -2913,6 +2701,11 @@
                     </a:solidFill>
                   </a:tcPr>
                 </a:tc>
+                <a:extLst>
+                  <a:ext uri="{0D108BD9-81ED-4DB2-BD59-A6C34878D82A}">
+                    <a16:rowId xmlns:a16="http://schemas.microsoft.com/office/drawing/2014/main" val="10000"/>
+                  </a:ext>
+                </a:extLst>
               </a:tr>
               <a:tr h="585216">
                 <a:tc>
@@ -2920,7 +2713,7 @@
                     <a:bodyPr/>
                     <a:lstStyle/>
                     <a:p>
-                      <a:pPr indent="0" marL="0">
+                      <a:pPr marL="0" indent="0">
                         <a:buNone/>
                       </a:pPr>
                       <a:r>
@@ -2941,7 +2734,7 @@
                       </a:endParaRPr>
                     </a:p>
                   </a:txBody>
-                  <a:tcPr marL="91440" marR="91440" marT="45720" marB="45720" anchor="ctr">
+                  <a:tcPr anchor="ctr">
                     <a:lnL w="12700" cap="flat" cmpd="sng" algn="ctr">
                       <a:solidFill>
                         <a:srgbClr val="D8E2F5"/>
@@ -2988,7 +2781,7 @@
                     <a:bodyPr/>
                     <a:lstStyle/>
                     <a:p>
-                      <a:pPr indent="0" marL="0">
+                      <a:pPr marL="0" indent="0">
                         <a:buNone/>
                       </a:pPr>
                       <a:r>
@@ -3009,7 +2802,7 @@
                       </a:endParaRPr>
                     </a:p>
                   </a:txBody>
-                  <a:tcPr marL="91440" marR="91440" marT="45720" marB="45720" anchor="ctr">
+                  <a:tcPr anchor="ctr">
                     <a:lnL w="12700" cap="flat" cmpd="sng" algn="ctr">
                       <a:solidFill>
                         <a:srgbClr val="D8E2F5"/>
@@ -3056,7 +2849,7 @@
                     <a:bodyPr/>
                     <a:lstStyle/>
                     <a:p>
-                      <a:pPr indent="0" marL="0">
+                      <a:pPr marL="0" indent="0">
                         <a:buNone/>
                       </a:pPr>
                       <a:r>
@@ -3077,7 +2870,7 @@
                       </a:endParaRPr>
                     </a:p>
                   </a:txBody>
-                  <a:tcPr marL="91440" marR="91440" marT="45720" marB="45720" anchor="ctr">
+                  <a:tcPr anchor="ctr">
                     <a:lnL w="12700" cap="flat" cmpd="sng" algn="ctr">
                       <a:solidFill>
                         <a:srgbClr val="D8E2F5"/>
@@ -3119,6 +2912,11 @@
                     </a:solidFill>
                   </a:tcPr>
                 </a:tc>
+                <a:extLst>
+                  <a:ext uri="{0D108BD9-81ED-4DB2-BD59-A6C34878D82A}">
+                    <a16:rowId xmlns:a16="http://schemas.microsoft.com/office/drawing/2014/main" val="10001"/>
+                  </a:ext>
+                </a:extLst>
               </a:tr>
               <a:tr h="585216">
                 <a:tc>
@@ -3126,7 +2924,7 @@
                     <a:bodyPr/>
                     <a:lstStyle/>
                     <a:p>
-                      <a:pPr indent="0" marL="0">
+                      <a:pPr marL="0" indent="0">
                         <a:buNone/>
                       </a:pPr>
                       <a:r>
@@ -3147,7 +2945,7 @@
                       </a:endParaRPr>
                     </a:p>
                   </a:txBody>
-                  <a:tcPr marL="91440" marR="91440" marT="45720" marB="45720" anchor="ctr">
+                  <a:tcPr anchor="ctr">
                     <a:lnL w="12700" cap="flat" cmpd="sng" algn="ctr">
                       <a:solidFill>
                         <a:srgbClr val="D8E2F5"/>
@@ -3194,7 +2992,7 @@
                     <a:bodyPr/>
                     <a:lstStyle/>
                     <a:p>
-                      <a:pPr indent="0" marL="0">
+                      <a:pPr marL="0" indent="0">
                         <a:buNone/>
                       </a:pPr>
                       <a:r>
@@ -3215,7 +3013,7 @@
                       </a:endParaRPr>
                     </a:p>
                   </a:txBody>
-                  <a:tcPr marL="91440" marR="91440" marT="45720" marB="45720" anchor="ctr">
+                  <a:tcPr anchor="ctr">
                     <a:lnL w="12700" cap="flat" cmpd="sng" algn="ctr">
                       <a:solidFill>
                         <a:srgbClr val="D8E2F5"/>
@@ -3262,7 +3060,7 @@
                     <a:bodyPr/>
                     <a:lstStyle/>
                     <a:p>
-                      <a:pPr indent="0" marL="0">
+                      <a:pPr marL="0" indent="0">
                         <a:buNone/>
                       </a:pPr>
                       <a:r>
@@ -3283,7 +3081,7 @@
                       </a:endParaRPr>
                     </a:p>
                   </a:txBody>
-                  <a:tcPr marL="91440" marR="91440" marT="45720" marB="45720" anchor="ctr">
+                  <a:tcPr anchor="ctr">
                     <a:lnL w="12700" cap="flat" cmpd="sng" algn="ctr">
                       <a:solidFill>
                         <a:srgbClr val="D8E2F5"/>
@@ -3325,6 +3123,11 @@
                     </a:solidFill>
                   </a:tcPr>
                 </a:tc>
+                <a:extLst>
+                  <a:ext uri="{0D108BD9-81ED-4DB2-BD59-A6C34878D82A}">
+                    <a16:rowId xmlns:a16="http://schemas.microsoft.com/office/drawing/2014/main" val="10002"/>
+                  </a:ext>
+                </a:extLst>
               </a:tr>
               <a:tr h="585216">
                 <a:tc>
@@ -3332,7 +3135,7 @@
                     <a:bodyPr/>
                     <a:lstStyle/>
                     <a:p>
-                      <a:pPr indent="0" marL="0">
+                      <a:pPr marL="0" indent="0">
                         <a:buNone/>
                       </a:pPr>
                       <a:r>
@@ -3353,7 +3156,7 @@
                       </a:endParaRPr>
                     </a:p>
                   </a:txBody>
-                  <a:tcPr marL="91440" marR="91440" marT="45720" marB="45720" anchor="ctr">
+                  <a:tcPr anchor="ctr">
                     <a:lnL w="12700" cap="flat" cmpd="sng" algn="ctr">
                       <a:solidFill>
                         <a:srgbClr val="D8E2F5"/>
@@ -3400,7 +3203,7 @@
                     <a:bodyPr/>
                     <a:lstStyle/>
                     <a:p>
-                      <a:pPr indent="0" marL="0">
+                      <a:pPr marL="0" indent="0">
                         <a:buNone/>
                       </a:pPr>
                       <a:r>
@@ -3421,7 +3224,7 @@
                       </a:endParaRPr>
                     </a:p>
                   </a:txBody>
-                  <a:tcPr marL="91440" marR="91440" marT="45720" marB="45720" anchor="ctr">
+                  <a:tcPr anchor="ctr">
                     <a:lnL w="12700" cap="flat" cmpd="sng" algn="ctr">
                       <a:solidFill>
                         <a:srgbClr val="D8E2F5"/>
@@ -3468,7 +3271,7 @@
                     <a:bodyPr/>
                     <a:lstStyle/>
                     <a:p>
-                      <a:pPr indent="0" marL="0">
+                      <a:pPr marL="0" indent="0">
                         <a:buNone/>
                       </a:pPr>
                       <a:r>
@@ -3489,7 +3292,7 @@
                       </a:endParaRPr>
                     </a:p>
                   </a:txBody>
-                  <a:tcPr marL="91440" marR="91440" marT="45720" marB="45720" anchor="ctr">
+                  <a:tcPr anchor="ctr">
                     <a:lnL w="12700" cap="flat" cmpd="sng" algn="ctr">
                       <a:solidFill>
                         <a:srgbClr val="D8E2F5"/>
@@ -3531,6 +3334,11 @@
                     </a:solidFill>
                   </a:tcPr>
                 </a:tc>
+                <a:extLst>
+                  <a:ext uri="{0D108BD9-81ED-4DB2-BD59-A6C34878D82A}">
+                    <a16:rowId xmlns:a16="http://schemas.microsoft.com/office/drawing/2014/main" val="10003"/>
+                  </a:ext>
+                </a:extLst>
               </a:tr>
               <a:tr h="585216">
                 <a:tc>
@@ -3538,7 +3346,7 @@
                     <a:bodyPr/>
                     <a:lstStyle/>
                     <a:p>
-                      <a:pPr indent="0" marL="0">
+                      <a:pPr marL="0" indent="0">
                         <a:buNone/>
                       </a:pPr>
                       <a:r>
@@ -3559,7 +3367,7 @@
                       </a:endParaRPr>
                     </a:p>
                   </a:txBody>
-                  <a:tcPr marL="91440" marR="91440" marT="45720" marB="45720" anchor="ctr">
+                  <a:tcPr anchor="ctr">
                     <a:lnL w="12700" cap="flat" cmpd="sng" algn="ctr">
                       <a:solidFill>
                         <a:srgbClr val="D8E2F5"/>
@@ -3606,7 +3414,7 @@
                     <a:bodyPr/>
                     <a:lstStyle/>
                     <a:p>
-                      <a:pPr indent="0" marL="0">
+                      <a:pPr marL="0" indent="0">
                         <a:buNone/>
                       </a:pPr>
                       <a:r>
@@ -3627,7 +3435,7 @@
                       </a:endParaRPr>
                     </a:p>
                   </a:txBody>
-                  <a:tcPr marL="91440" marR="91440" marT="45720" marB="45720" anchor="ctr">
+                  <a:tcPr anchor="ctr">
                     <a:lnL w="12700" cap="flat" cmpd="sng" algn="ctr">
                       <a:solidFill>
                         <a:srgbClr val="D8E2F5"/>
@@ -3674,7 +3482,7 @@
                     <a:bodyPr/>
                     <a:lstStyle/>
                     <a:p>
-                      <a:pPr indent="0" marL="0">
+                      <a:pPr marL="0" indent="0">
                         <a:buNone/>
                       </a:pPr>
                       <a:r>
@@ -3695,7 +3503,7 @@
                       </a:endParaRPr>
                     </a:p>
                   </a:txBody>
-                  <a:tcPr marL="91440" marR="91440" marT="45720" marB="45720" anchor="ctr">
+                  <a:tcPr anchor="ctr">
                     <a:lnL w="12700" cap="flat" cmpd="sng" algn="ctr">
                       <a:solidFill>
                         <a:srgbClr val="D8E2F5"/>
@@ -3737,6 +3545,11 @@
                     </a:solidFill>
                   </a:tcPr>
                 </a:tc>
+                <a:extLst>
+                  <a:ext uri="{0D108BD9-81ED-4DB2-BD59-A6C34878D82A}">
+                    <a16:rowId xmlns:a16="http://schemas.microsoft.com/office/drawing/2014/main" val="10004"/>
+                  </a:ext>
+                </a:extLst>
               </a:tr>
               <a:tr h="585216">
                 <a:tc>
@@ -3744,7 +3557,7 @@
                     <a:bodyPr/>
                     <a:lstStyle/>
                     <a:p>
-                      <a:pPr indent="0" marL="0">
+                      <a:pPr marL="0" indent="0">
                         <a:buNone/>
                       </a:pPr>
                       <a:r>
@@ -3765,7 +3578,7 @@
                       </a:endParaRPr>
                     </a:p>
                   </a:txBody>
-                  <a:tcPr marL="91440" marR="91440" marT="45720" marB="45720" anchor="ctr">
+                  <a:tcPr anchor="ctr">
                     <a:lnL w="12700" cap="flat" cmpd="sng" algn="ctr">
                       <a:solidFill>
                         <a:srgbClr val="D8E2F5"/>
@@ -3812,7 +3625,7 @@
                     <a:bodyPr/>
                     <a:lstStyle/>
                     <a:p>
-                      <a:pPr indent="0" marL="0">
+                      <a:pPr marL="0" indent="0">
                         <a:buNone/>
                       </a:pPr>
                       <a:r>
@@ -3833,7 +3646,7 @@
                       </a:endParaRPr>
                     </a:p>
                   </a:txBody>
-                  <a:tcPr marL="91440" marR="91440" marT="45720" marB="45720" anchor="ctr">
+                  <a:tcPr anchor="ctr">
                     <a:lnL w="12700" cap="flat" cmpd="sng" algn="ctr">
                       <a:solidFill>
                         <a:srgbClr val="D8E2F5"/>
@@ -3880,7 +3693,7 @@
                     <a:bodyPr/>
                     <a:lstStyle/>
                     <a:p>
-                      <a:pPr indent="0" marL="0">
+                      <a:pPr marL="0" indent="0">
                         <a:buNone/>
                       </a:pPr>
                       <a:r>
@@ -3901,7 +3714,7 @@
                       </a:endParaRPr>
                     </a:p>
                   </a:txBody>
-                  <a:tcPr marL="91440" marR="91440" marT="45720" marB="45720" anchor="ctr">
+                  <a:tcPr anchor="ctr">
                     <a:lnL w="12700" cap="flat" cmpd="sng" algn="ctr">
                       <a:solidFill>
                         <a:srgbClr val="D8E2F5"/>
@@ -3943,6 +3756,11 @@
                     </a:solidFill>
                   </a:tcPr>
                 </a:tc>
+                <a:extLst>
+                  <a:ext uri="{0D108BD9-81ED-4DB2-BD59-A6C34878D82A}">
+                    <a16:rowId xmlns:a16="http://schemas.microsoft.com/office/drawing/2014/main" val="10005"/>
+                  </a:ext>
+                </a:extLst>
               </a:tr>
             </a:tbl>
           </a:graphicData>
@@ -3991,7 +3809,7 @@
           <a:bodyPr wrap="square" rtlCol="0" anchor="ctr"/>
           <a:lstStyle/>
           <a:p>
-            <a:pPr indent="0" marL="0">
+            <a:pPr marL="0" indent="0">
               <a:buNone/>
             </a:pPr>
             <a:r>
@@ -4030,7 +3848,7 @@
           <a:bodyPr wrap="square" rtlCol="0" anchor="ctr"/>
           <a:lstStyle/>
           <a:p>
-            <a:pPr indent="0" marL="0">
+            <a:pPr marL="0" indent="0">
               <a:buNone/>
             </a:pPr>
             <a:r>
@@ -4050,7 +3868,7 @@
       </p:sp>
       <p:sp>
         <p:nvSpPr>
-          <p:cNvPr id="11" name="Text 8"/>
+          <p:cNvPr id="7" name="Text 8"/>
           <p:cNvSpPr/>
           <p:nvPr/>
         </p:nvSpPr>
@@ -4069,7 +3887,7 @@
           <a:bodyPr wrap="square" rtlCol="0" anchor="ctr"/>
           <a:lstStyle/>
           <a:p>
-            <a:pPr algn="r" indent="0" marL="0">
+            <a:pPr marL="0" indent="0" algn="r">
               <a:buNone/>
             </a:pPr>
             <a:r>
@@ -4103,6 +3921,7 @@
         <a:solidFill>
           <a:srgbClr val="FFFFFF"/>
         </a:solidFill>
+        <a:effectLst/>
       </p:bgPr>
     </p:bg>
     <p:spTree>
@@ -4140,11 +3959,11 @@
           <a:bodyPr wrap="square" rtlCol="0" anchor="ctr"/>
           <a:lstStyle/>
           <a:p>
-            <a:pPr indent="0" marL="0">
-              <a:buNone/>
-            </a:pPr>
-            <a:r>
-              <a:rPr lang="en-US" sz="1200" b="1" spc="200" kern="0" dirty="0">
+            <a:pPr marL="0" indent="0">
+              <a:buNone/>
+            </a:pPr>
+            <a:r>
+              <a:rPr lang="en-US" sz="1200" b="1" kern="0" spc="200" dirty="0">
                 <a:solidFill>
                   <a:srgbClr val="F96167"/>
                 </a:solidFill>
@@ -4179,7 +3998,7 @@
           <a:bodyPr wrap="square" rtlCol="0" anchor="ctr"/>
           <a:lstStyle/>
           <a:p>
-            <a:pPr indent="0" marL="0">
+            <a:pPr marL="0" indent="0">
               <a:buNone/>
             </a:pPr>
             <a:r>
@@ -4317,7 +4136,7 @@
           <a:bodyPr wrap="square" rtlCol="0" anchor="ctr"/>
           <a:lstStyle/>
           <a:p>
-            <a:pPr indent="0" marL="0">
+            <a:pPr marL="0" indent="0">
               <a:buNone/>
             </a:pPr>
             <a:r>
@@ -4353,7 +4172,7 @@
           <a:bodyPr wrap="square" rtlCol="0" anchor="ctr"/>
           <a:lstStyle/>
           <a:p>
-            <a:pPr indent="0" marL="0">
+            <a:pPr marL="0" indent="0">
               <a:buNone/>
             </a:pPr>
             <a:r>
@@ -4392,7 +4211,7 @@
           <a:bodyPr wrap="square" rtlCol="0" anchor="ctr"/>
           <a:lstStyle/>
           <a:p>
-            <a:pPr algn="r" indent="0" marL="0">
+            <a:pPr marL="0" indent="0" algn="r">
               <a:buNone/>
             </a:pPr>
             <a:r>
@@ -4431,7 +4250,7 @@
           <a:bodyPr wrap="square" rtlCol="0" anchor="ctr"/>
           <a:lstStyle/>
           <a:p>
-            <a:pPr indent="0" marL="0">
+            <a:pPr marL="0" indent="0">
               <a:lnSpc>
                 <a:spcPts val="1900"/>
               </a:lnSpc>
@@ -4500,7 +4319,7 @@
           <a:bodyPr wrap="square" rtlCol="0" anchor="ctr"/>
           <a:lstStyle/>
           <a:p>
-            <a:pPr indent="0" marL="0">
+            <a:pPr marL="0" indent="0">
               <a:buNone/>
             </a:pPr>
             <a:r>
@@ -4536,7 +4355,7 @@
           <a:bodyPr wrap="square" rtlCol="0" anchor="ctr"/>
           <a:lstStyle/>
           <a:p>
-            <a:pPr indent="0" marL="0">
+            <a:pPr marL="0" indent="0">
               <a:buNone/>
             </a:pPr>
             <a:r>
@@ -4575,7 +4394,7 @@
           <a:bodyPr wrap="square" rtlCol="0" anchor="ctr"/>
           <a:lstStyle/>
           <a:p>
-            <a:pPr algn="r" indent="0" marL="0">
+            <a:pPr marL="0" indent="0" algn="r">
               <a:buNone/>
             </a:pPr>
             <a:r>
@@ -4614,7 +4433,7 @@
           <a:bodyPr wrap="square" rtlCol="0" anchor="ctr"/>
           <a:lstStyle/>
           <a:p>
-            <a:pPr indent="0" marL="0">
+            <a:pPr marL="0" indent="0">
               <a:lnSpc>
                 <a:spcPts val="1900"/>
               </a:lnSpc>
@@ -4683,7 +4502,7 @@
           <a:bodyPr wrap="square" rtlCol="0" anchor="ctr"/>
           <a:lstStyle/>
           <a:p>
-            <a:pPr indent="0" marL="0">
+            <a:pPr marL="0" indent="0">
               <a:buNone/>
             </a:pPr>
             <a:r>
@@ -4719,7 +4538,7 @@
           <a:bodyPr wrap="square" rtlCol="0" anchor="ctr"/>
           <a:lstStyle/>
           <a:p>
-            <a:pPr indent="0" marL="0">
+            <a:pPr marL="0" indent="0">
               <a:buNone/>
             </a:pPr>
             <a:r>
@@ -4758,7 +4577,7 @@
           <a:bodyPr wrap="square" rtlCol="0" anchor="ctr"/>
           <a:lstStyle/>
           <a:p>
-            <a:pPr algn="r" indent="0" marL="0">
+            <a:pPr marL="0" indent="0" algn="r">
               <a:buNone/>
             </a:pPr>
             <a:r>
@@ -4797,7 +4616,7 @@
           <a:bodyPr wrap="square" rtlCol="0" anchor="ctr"/>
           <a:lstStyle/>
           <a:p>
-            <a:pPr indent="0" marL="0">
+            <a:pPr marL="0" indent="0">
               <a:lnSpc>
                 <a:spcPts val="1900"/>
               </a:lnSpc>
@@ -4866,7 +4685,7 @@
           <a:bodyPr wrap="square" rtlCol="0" anchor="ctr"/>
           <a:lstStyle/>
           <a:p>
-            <a:pPr indent="0" marL="0">
+            <a:pPr marL="0" indent="0">
               <a:buNone/>
             </a:pPr>
             <a:r>
@@ -4902,7 +4721,7 @@
           <a:bodyPr wrap="square" rtlCol="0" anchor="ctr"/>
           <a:lstStyle/>
           <a:p>
-            <a:pPr indent="0" marL="0">
+            <a:pPr marL="0" indent="0">
               <a:buNone/>
             </a:pPr>
             <a:r>
@@ -4941,7 +4760,7 @@
           <a:bodyPr wrap="square" rtlCol="0" anchor="ctr"/>
           <a:lstStyle/>
           <a:p>
-            <a:pPr algn="r" indent="0" marL="0">
+            <a:pPr marL="0" indent="0" algn="r">
               <a:buNone/>
             </a:pPr>
             <a:r>
@@ -4980,7 +4799,7 @@
           <a:bodyPr wrap="square" rtlCol="0" anchor="ctr"/>
           <a:lstStyle/>
           <a:p>
-            <a:pPr indent="0" marL="0">
+            <a:pPr marL="0" indent="0">
               <a:lnSpc>
                 <a:spcPts val="1900"/>
               </a:lnSpc>
@@ -5022,7 +4841,7 @@
           <a:bodyPr wrap="square" rtlCol="0" anchor="ctr"/>
           <a:lstStyle/>
           <a:p>
-            <a:pPr indent="0" marL="0">
+            <a:pPr marL="0" indent="0">
               <a:lnSpc>
                 <a:spcPts val="1800"/>
               </a:lnSpc>
@@ -5064,7 +4883,7 @@
           <a:bodyPr wrap="square" rtlCol="0" anchor="ctr"/>
           <a:lstStyle/>
           <a:p>
-            <a:pPr indent="0" marL="0">
+            <a:pPr marL="0" indent="0">
               <a:buNone/>
             </a:pPr>
             <a:r>
@@ -5103,7 +4922,7 @@
           <a:bodyPr wrap="square" rtlCol="0" anchor="ctr"/>
           <a:lstStyle/>
           <a:p>
-            <a:pPr algn="r" indent="0" marL="0">
+            <a:pPr marL="0" indent="0" algn="r">
               <a:buNone/>
             </a:pPr>
             <a:r>
@@ -5137,6 +4956,7 @@
         <a:solidFill>
           <a:srgbClr val="FFFFFF"/>
         </a:solidFill>
+        <a:effectLst/>
       </p:bgPr>
     </p:bg>
     <p:spTree>
@@ -5174,11 +4994,11 @@
           <a:bodyPr wrap="square" rtlCol="0" anchor="ctr"/>
           <a:lstStyle/>
           <a:p>
-            <a:pPr indent="0" marL="0">
-              <a:buNone/>
-            </a:pPr>
-            <a:r>
-              <a:rPr lang="en-US" sz="1200" b="1" spc="200" kern="0" dirty="0">
+            <a:pPr marL="0" indent="0">
+              <a:buNone/>
+            </a:pPr>
+            <a:r>
+              <a:rPr lang="en-US" sz="1200" b="1" kern="0" spc="200" dirty="0">
                 <a:solidFill>
                   <a:srgbClr val="F96167"/>
                 </a:solidFill>
@@ -5213,7 +5033,7 @@
           <a:bodyPr wrap="square" rtlCol="0" anchor="ctr"/>
           <a:lstStyle/>
           <a:p>
-            <a:pPr indent="0" marL="0">
+            <a:pPr marL="0" indent="0">
               <a:buNone/>
             </a:pPr>
             <a:r>
@@ -5353,7 +5173,7 @@
           <a:bodyPr wrap="square" rtlCol="0" anchor="ctr"/>
           <a:lstStyle/>
           <a:p>
-            <a:pPr algn="ctr" indent="0" marL="0">
+            <a:pPr marL="0" indent="0" algn="ctr">
               <a:buNone/>
             </a:pPr>
             <a:r>
@@ -5392,7 +5212,7 @@
           <a:bodyPr wrap="square" rtlCol="0" anchor="ctr"/>
           <a:lstStyle/>
           <a:p>
-            <a:pPr indent="0" marL="0">
+            <a:pPr marL="0" indent="0">
               <a:buNone/>
             </a:pPr>
             <a:r>
@@ -5431,7 +5251,7 @@
           <a:bodyPr wrap="square" rtlCol="0" anchor="ctr"/>
           <a:lstStyle/>
           <a:p>
-            <a:pPr indent="0" marL="0">
+            <a:pPr marL="0" indent="0">
               <a:lnSpc>
                 <a:spcPts val="1900"/>
               </a:lnSpc>
@@ -5502,7 +5322,7 @@
           <a:bodyPr wrap="square" rtlCol="0" anchor="ctr"/>
           <a:lstStyle/>
           <a:p>
-            <a:pPr algn="ctr" indent="0" marL="0">
+            <a:pPr marL="0" indent="0" algn="ctr">
               <a:buNone/>
             </a:pPr>
             <a:r>
@@ -5541,7 +5361,7 @@
           <a:bodyPr wrap="square" rtlCol="0" anchor="ctr"/>
           <a:lstStyle/>
           <a:p>
-            <a:pPr indent="0" marL="0">
+            <a:pPr marL="0" indent="0">
               <a:buNone/>
             </a:pPr>
             <a:r>
@@ -5580,7 +5400,7 @@
           <a:bodyPr wrap="square" rtlCol="0" anchor="ctr"/>
           <a:lstStyle/>
           <a:p>
-            <a:pPr indent="0" marL="0">
+            <a:pPr marL="0" indent="0">
               <a:lnSpc>
                 <a:spcPts val="1900"/>
               </a:lnSpc>
@@ -5622,7 +5442,7 @@
           <a:bodyPr wrap="square" rtlCol="0" anchor="ctr"/>
           <a:lstStyle/>
           <a:p>
-            <a:pPr indent="0" marL="0">
+            <a:pPr marL="0" indent="0">
               <a:buNone/>
             </a:pPr>
             <a:r>
@@ -5661,7 +5481,7 @@
           <a:bodyPr wrap="square" rtlCol="0" anchor="ctr"/>
           <a:lstStyle/>
           <a:p>
-            <a:pPr indent="0" marL="0">
+            <a:pPr marL="0" indent="0">
               <a:buNone/>
             </a:pPr>
             <a:r>
@@ -5700,7 +5520,7 @@
           <a:bodyPr wrap="square" rtlCol="0" anchor="ctr"/>
           <a:lstStyle/>
           <a:p>
-            <a:pPr algn="r" indent="0" marL="0">
+            <a:pPr marL="0" indent="0" algn="r">
               <a:buNone/>
             </a:pPr>
             <a:r>
@@ -5734,6 +5554,7 @@
         <a:solidFill>
           <a:srgbClr val="1E2761"/>
         </a:solidFill>
+        <a:effectLst/>
       </p:bgPr>
     </p:bg>
     <p:spTree>
@@ -5843,11 +5664,11 @@
           <a:bodyPr wrap="square" rtlCol="0" anchor="ctr"/>
           <a:lstStyle/>
           <a:p>
-            <a:pPr indent="0" marL="0">
-              <a:buNone/>
-            </a:pPr>
-            <a:r>
-              <a:rPr lang="en-US" sz="1200" b="1" spc="200" kern="0" dirty="0">
+            <a:pPr marL="0" indent="0">
+              <a:buNone/>
+            </a:pPr>
+            <a:r>
+              <a:rPr lang="en-US" sz="1200" b="1" kern="0" spc="200" dirty="0">
                 <a:solidFill>
                   <a:srgbClr val="F96167"/>
                 </a:solidFill>
@@ -5882,7 +5703,7 @@
           <a:bodyPr wrap="square" rtlCol="0" anchor="ctr"/>
           <a:lstStyle/>
           <a:p>
-            <a:pPr indent="0" marL="0">
+            <a:pPr marL="0" indent="0">
               <a:buNone/>
             </a:pPr>
             <a:r>
@@ -5943,7 +5764,7 @@
           <a:bodyPr wrap="square" rtlCol="0" anchor="ctr"/>
           <a:lstStyle/>
           <a:p>
-            <a:pPr indent="0" marL="0">
+            <a:pPr marL="0" indent="0">
               <a:buNone/>
             </a:pPr>
             <a:r>
@@ -5982,7 +5803,7 @@
           <a:bodyPr wrap="square" rtlCol="0" anchor="ctr"/>
           <a:lstStyle/>
           <a:p>
-            <a:pPr indent="0" marL="0">
+            <a:pPr marL="0" indent="0">
               <a:lnSpc>
                 <a:spcPts val="2000"/>
               </a:lnSpc>
@@ -6046,7 +5867,7 @@
           <a:bodyPr wrap="square" rtlCol="0" anchor="ctr"/>
           <a:lstStyle/>
           <a:p>
-            <a:pPr indent="0" marL="0">
+            <a:pPr marL="0" indent="0">
               <a:buNone/>
             </a:pPr>
             <a:r>
@@ -6085,7 +5906,7 @@
           <a:bodyPr wrap="square" rtlCol="0" anchor="ctr"/>
           <a:lstStyle/>
           <a:p>
-            <a:pPr indent="0" marL="0">
+            <a:pPr marL="0" indent="0">
               <a:lnSpc>
                 <a:spcPts val="2000"/>
               </a:lnSpc>
@@ -6105,7 +5926,7 @@
             <a:endParaRPr lang="en-US" sz="1300" dirty="0"/>
           </a:p>
           <a:p>
-            <a:pPr indent="0" marL="0">
+            <a:pPr marL="0" indent="0">
               <a:lnSpc>
                 <a:spcPts val="2000"/>
               </a:lnSpc>
@@ -6170,7 +5991,7 @@
           <a:bodyPr wrap="square" rtlCol="0" anchor="ctr"/>
           <a:lstStyle/>
           <a:p>
-            <a:pPr indent="0" marL="0">
+            <a:pPr marL="0" indent="0">
               <a:lnSpc>
                 <a:spcPts val="2600"/>
               </a:lnSpc>
@@ -6189,12 +6010,6 @@
 not just the person who presses go.”
 </a:t>
             </a:r>
-            <a:pPr indent="0" marL="0">
-              <a:lnSpc>
-                <a:spcPts val="2600"/>
-              </a:lnSpc>
-              <a:buNone/>
-            </a:pPr>
             <a:r>
               <a:rPr lang="en-US" sz="1350" dirty="0">
                 <a:solidFill>
@@ -6231,7 +6046,7 @@
           <a:bodyPr wrap="square" rtlCol="0" anchor="ctr"/>
           <a:lstStyle/>
           <a:p>
-            <a:pPr indent="0" marL="0">
+            <a:pPr marL="0" indent="0">
               <a:buNone/>
             </a:pPr>
             <a:r>
@@ -6272,7 +6087,7 @@
           <a:bodyPr wrap="square" rtlCol="0" anchor="ctr"/>
           <a:lstStyle/>
           <a:p>
-            <a:pPr algn="r" indent="0" marL="0">
+            <a:pPr marL="0" indent="0" algn="r">
               <a:buNone/>
             </a:pPr>
             <a:r>
@@ -6308,6 +6123,7 @@
         <a:solidFill>
           <a:srgbClr val="FFFFFF"/>
         </a:solidFill>
+        <a:effectLst/>
       </p:bgPr>
     </p:bg>
     <p:spTree>
@@ -6345,11 +6161,11 @@
           <a:bodyPr wrap="square" rtlCol="0" anchor="ctr"/>
           <a:lstStyle/>
           <a:p>
-            <a:pPr indent="0" marL="0">
-              <a:buNone/>
-            </a:pPr>
-            <a:r>
-              <a:rPr lang="en-US" sz="1200" b="1" spc="200" kern="0" dirty="0">
+            <a:pPr marL="0" indent="0">
+              <a:buNone/>
+            </a:pPr>
+            <a:r>
+              <a:rPr lang="en-US" sz="1200" b="1" kern="0" spc="200" dirty="0">
                 <a:solidFill>
                   <a:srgbClr val="F96167"/>
                 </a:solidFill>
@@ -6384,7 +6200,7 @@
           <a:bodyPr wrap="square" rtlCol="0" anchor="ctr"/>
           <a:lstStyle/>
           <a:p>
-            <a:pPr indent="0" marL="0">
+            <a:pPr marL="0" indent="0">
               <a:buNone/>
             </a:pPr>
             <a:r>
@@ -6522,7 +6338,7 @@
           <a:bodyPr wrap="square" rtlCol="0" anchor="ctr"/>
           <a:lstStyle/>
           <a:p>
-            <a:pPr indent="0" marL="0">
+            <a:pPr marL="0" indent="0">
               <a:buNone/>
             </a:pPr>
             <a:r>
@@ -6561,7 +6377,7 @@
           <a:bodyPr wrap="square" rtlCol="0" anchor="ctr"/>
           <a:lstStyle/>
           <a:p>
-            <a:pPr indent="0" marL="0">
+            <a:pPr marL="0" indent="0">
               <a:lnSpc>
                 <a:spcPts val="1900"/>
               </a:lnSpc>
@@ -6581,7 +6397,7 @@
             <a:endParaRPr lang="en-US" sz="1250" dirty="0"/>
           </a:p>
           <a:p>
-            <a:pPr indent="0" marL="0">
+            <a:pPr marL="0" indent="0">
               <a:lnSpc>
                 <a:spcPts val="1900"/>
               </a:lnSpc>
@@ -6650,7 +6466,7 @@
           <a:bodyPr wrap="square" rtlCol="0" anchor="ctr"/>
           <a:lstStyle/>
           <a:p>
-            <a:pPr indent="0" marL="0">
+            <a:pPr marL="0" indent="0">
               <a:buNone/>
             </a:pPr>
             <a:r>
@@ -6689,7 +6505,7 @@
           <a:bodyPr wrap="square" rtlCol="0" anchor="ctr"/>
           <a:lstStyle/>
           <a:p>
-            <a:pPr indent="0" marL="0">
+            <a:pPr marL="0" indent="0">
               <a:lnSpc>
                 <a:spcPts val="1900"/>
               </a:lnSpc>
@@ -6709,7 +6525,7 @@
             <a:endParaRPr lang="en-US" sz="1250" dirty="0"/>
           </a:p>
           <a:p>
-            <a:pPr indent="0" marL="0">
+            <a:pPr marL="0" indent="0">
               <a:lnSpc>
                 <a:spcPts val="1900"/>
               </a:lnSpc>
@@ -6778,7 +6594,7 @@
           <a:bodyPr wrap="square" rtlCol="0" anchor="ctr"/>
           <a:lstStyle/>
           <a:p>
-            <a:pPr indent="0" marL="0">
+            <a:pPr marL="0" indent="0">
               <a:buNone/>
             </a:pPr>
             <a:r>
@@ -6817,7 +6633,7 @@
           <a:bodyPr wrap="square" rtlCol="0" anchor="ctr"/>
           <a:lstStyle/>
           <a:p>
-            <a:pPr indent="0" marL="0">
+            <a:pPr marL="0" indent="0">
               <a:lnSpc>
                 <a:spcPts val="1900"/>
               </a:lnSpc>
@@ -6837,7 +6653,7 @@
             <a:endParaRPr lang="en-US" sz="1250" dirty="0"/>
           </a:p>
           <a:p>
-            <a:pPr indent="0" marL="0">
+            <a:pPr marL="0" indent="0">
               <a:lnSpc>
                 <a:spcPts val="1900"/>
               </a:lnSpc>
@@ -6906,7 +6722,7 @@
           <a:bodyPr wrap="square" rtlCol="0" anchor="ctr"/>
           <a:lstStyle/>
           <a:p>
-            <a:pPr indent="0" marL="0">
+            <a:pPr marL="0" indent="0">
               <a:lnSpc>
                 <a:spcPts val="2200"/>
               </a:lnSpc>
@@ -6923,12 +6739,6 @@
               </a:rPr>
               <a:t>一句话带走：</a:t>
             </a:r>
-            <a:pPr indent="0" marL="0">
-              <a:lnSpc>
-                <a:spcPts val="2200"/>
-              </a:lnSpc>
-              <a:buNone/>
-            </a:pPr>
             <a:r>
               <a:rPr lang="en-US" sz="1450" dirty="0">
                 <a:solidFill>
@@ -6965,7 +6775,7 @@
           <a:bodyPr wrap="square" rtlCol="0" anchor="ctr"/>
           <a:lstStyle/>
           <a:p>
-            <a:pPr indent="0" marL="0">
+            <a:pPr marL="0" indent="0">
               <a:buNone/>
             </a:pPr>
             <a:r>
@@ -7004,7 +6814,7 @@
           <a:bodyPr wrap="square" rtlCol="0" anchor="ctr"/>
           <a:lstStyle/>
           <a:p>
-            <a:pPr algn="r" indent="0" marL="0">
+            <a:pPr marL="0" indent="0" algn="r">
               <a:buNone/>
             </a:pPr>
             <a:r>
@@ -7038,6 +6848,7 @@
         <a:solidFill>
           <a:srgbClr val="FFFFFF"/>
         </a:solidFill>
+        <a:effectLst/>
       </p:bgPr>
     </p:bg>
     <p:spTree>
@@ -7075,11 +6886,11 @@
           <a:bodyPr wrap="square" rtlCol="0" anchor="ctr"/>
           <a:lstStyle/>
           <a:p>
-            <a:pPr indent="0" marL="0">
-              <a:buNone/>
-            </a:pPr>
-            <a:r>
-              <a:rPr lang="en-US" sz="1200" b="1" spc="200" kern="0" dirty="0">
+            <a:pPr marL="0" indent="0">
+              <a:buNone/>
+            </a:pPr>
+            <a:r>
+              <a:rPr lang="en-US" sz="1200" b="1" kern="0" spc="200" dirty="0">
                 <a:solidFill>
                   <a:srgbClr val="F96167"/>
                 </a:solidFill>
@@ -7114,7 +6925,7 @@
           <a:bodyPr wrap="square" rtlCol="0" anchor="ctr"/>
           <a:lstStyle/>
           <a:p>
-            <a:pPr indent="0" marL="0">
+            <a:pPr marL="0" indent="0">
               <a:buNone/>
             </a:pPr>
             <a:r>
@@ -7227,7 +7038,7 @@
           <a:bodyPr wrap="square" rtlCol="0" anchor="ctr"/>
           <a:lstStyle/>
           <a:p>
-            <a:pPr algn="ctr" indent="0" marL="0">
+            <a:pPr marL="0" indent="0" algn="ctr">
               <a:buNone/>
             </a:pPr>
             <a:r>
@@ -7266,7 +7077,7 @@
           <a:bodyPr wrap="square" rtlCol="0" anchor="t"/>
           <a:lstStyle/>
           <a:p>
-            <a:pPr indent="0" marL="0">
+            <a:pPr marL="0" indent="0">
               <a:lnSpc>
                 <a:spcPts val="1600"/>
               </a:lnSpc>
@@ -7308,7 +7119,7 @@
           <a:bodyPr wrap="square" rtlCol="0" anchor="t"/>
           <a:lstStyle/>
           <a:p>
-            <a:pPr indent="0" marL="0">
+            <a:pPr marL="0" indent="0">
               <a:lnSpc>
                 <a:spcPts val="1600"/>
               </a:lnSpc>
@@ -7352,7 +7163,7 @@
           <a:bodyPr wrap="square" rtlCol="0" anchor="ctr"/>
           <a:lstStyle/>
           <a:p>
-            <a:pPr algn="ctr" indent="0" marL="0">
+            <a:pPr marL="0" indent="0" algn="ctr">
               <a:buNone/>
             </a:pPr>
             <a:r>
@@ -7391,7 +7202,7 @@
           <a:bodyPr wrap="square" rtlCol="0" anchor="t"/>
           <a:lstStyle/>
           <a:p>
-            <a:pPr indent="0" marL="0">
+            <a:pPr marL="0" indent="0">
               <a:lnSpc>
                 <a:spcPts val="1600"/>
               </a:lnSpc>
@@ -7433,7 +7244,7 @@
           <a:bodyPr wrap="square" rtlCol="0" anchor="t"/>
           <a:lstStyle/>
           <a:p>
-            <a:pPr indent="0" marL="0">
+            <a:pPr marL="0" indent="0">
               <a:lnSpc>
                 <a:spcPts val="1600"/>
               </a:lnSpc>
@@ -7477,7 +7288,7 @@
           <a:bodyPr wrap="square" rtlCol="0" anchor="ctr"/>
           <a:lstStyle/>
           <a:p>
-            <a:pPr algn="ctr" indent="0" marL="0">
+            <a:pPr marL="0" indent="0" algn="ctr">
               <a:buNone/>
             </a:pPr>
             <a:r>
@@ -7516,7 +7327,7 @@
           <a:bodyPr wrap="square" rtlCol="0" anchor="t"/>
           <a:lstStyle/>
           <a:p>
-            <a:pPr indent="0" marL="0">
+            <a:pPr marL="0" indent="0">
               <a:lnSpc>
                 <a:spcPts val="1600"/>
               </a:lnSpc>
@@ -7558,7 +7369,7 @@
           <a:bodyPr wrap="square" rtlCol="0" anchor="t"/>
           <a:lstStyle/>
           <a:p>
-            <a:pPr indent="0" marL="0">
+            <a:pPr marL="0" indent="0">
               <a:lnSpc>
                 <a:spcPts val="1600"/>
               </a:lnSpc>
@@ -7602,7 +7413,7 @@
           <a:bodyPr wrap="square" rtlCol="0" anchor="ctr"/>
           <a:lstStyle/>
           <a:p>
-            <a:pPr algn="ctr" indent="0" marL="0">
+            <a:pPr marL="0" indent="0" algn="ctr">
               <a:buNone/>
             </a:pPr>
             <a:r>
@@ -7641,7 +7452,7 @@
           <a:bodyPr wrap="square" rtlCol="0" anchor="t"/>
           <a:lstStyle/>
           <a:p>
-            <a:pPr indent="0" marL="0">
+            <a:pPr marL="0" indent="0">
               <a:lnSpc>
                 <a:spcPts val="1600"/>
               </a:lnSpc>
@@ -7683,7 +7494,7 @@
           <a:bodyPr wrap="square" rtlCol="0" anchor="t"/>
           <a:lstStyle/>
           <a:p>
-            <a:pPr indent="0" marL="0">
+            <a:pPr marL="0" indent="0">
               <a:lnSpc>
                 <a:spcPts val="1600"/>
               </a:lnSpc>
@@ -7727,7 +7538,7 @@
           <a:bodyPr wrap="square" rtlCol="0" anchor="ctr"/>
           <a:lstStyle/>
           <a:p>
-            <a:pPr algn="ctr" indent="0" marL="0">
+            <a:pPr marL="0" indent="0" algn="ctr">
               <a:buNone/>
             </a:pPr>
             <a:r>
@@ -7766,7 +7577,7 @@
           <a:bodyPr wrap="square" rtlCol="0" anchor="t"/>
           <a:lstStyle/>
           <a:p>
-            <a:pPr indent="0" marL="0">
+            <a:pPr marL="0" indent="0">
               <a:lnSpc>
                 <a:spcPts val="1600"/>
               </a:lnSpc>
@@ -7808,7 +7619,7 @@
           <a:bodyPr wrap="square" rtlCol="0" anchor="t"/>
           <a:lstStyle/>
           <a:p>
-            <a:pPr indent="0" marL="0">
+            <a:pPr marL="0" indent="0">
               <a:lnSpc>
                 <a:spcPts val="1600"/>
               </a:lnSpc>
@@ -7850,7 +7661,7 @@
           <a:bodyPr wrap="square" rtlCol="0" anchor="ctr"/>
           <a:lstStyle/>
           <a:p>
-            <a:pPr indent="0" marL="0">
+            <a:pPr marL="0" indent="0">
               <a:buNone/>
             </a:pPr>
             <a:r>
@@ -7889,7 +7700,7 @@
           <a:bodyPr wrap="square" rtlCol="0" anchor="ctr"/>
           <a:lstStyle/>
           <a:p>
-            <a:pPr algn="r" indent="0" marL="0">
+            <a:pPr marL="0" indent="0" algn="r">
               <a:buNone/>
             </a:pPr>
             <a:r>
@@ -7923,6 +7734,7 @@
         <a:solidFill>
           <a:srgbClr val="FFFFFF"/>
         </a:solidFill>
+        <a:effectLst/>
       </p:bgPr>
     </p:bg>
     <p:spTree>
@@ -7960,11 +7772,11 @@
           <a:bodyPr wrap="square" rtlCol="0" anchor="ctr"/>
           <a:lstStyle/>
           <a:p>
-            <a:pPr indent="0" marL="0">
-              <a:buNone/>
-            </a:pPr>
-            <a:r>
-              <a:rPr lang="en-US" sz="1200" b="1" spc="200" kern="0" dirty="0">
+            <a:pPr marL="0" indent="0">
+              <a:buNone/>
+            </a:pPr>
+            <a:r>
+              <a:rPr lang="en-US" sz="1200" b="1" kern="0" spc="200" dirty="0">
                 <a:solidFill>
                   <a:srgbClr val="F96167"/>
                 </a:solidFill>
@@ -7999,7 +7811,7 @@
           <a:bodyPr wrap="square" rtlCol="0" anchor="ctr"/>
           <a:lstStyle/>
           <a:p>
-            <a:pPr indent="0" marL="0">
+            <a:pPr marL="0" indent="0">
               <a:buNone/>
             </a:pPr>
             <a:r>
@@ -8137,7 +7949,7 @@
           <a:bodyPr wrap="square" rtlCol="0" anchor="ctr"/>
           <a:lstStyle/>
           <a:p>
-            <a:pPr indent="0" marL="0">
+            <a:pPr marL="0" indent="0">
               <a:buNone/>
             </a:pPr>
             <a:r>
@@ -8176,7 +7988,7 @@
           <a:bodyPr wrap="square" rtlCol="0" anchor="ctr"/>
           <a:lstStyle/>
           <a:p>
-            <a:pPr indent="0" marL="0">
+            <a:pPr marL="0" indent="0">
               <a:buNone/>
             </a:pPr>
             <a:r>
@@ -8215,7 +8027,7 @@
           <a:bodyPr wrap="square" rtlCol="0" anchor="ctr"/>
           <a:lstStyle/>
           <a:p>
-            <a:pPr indent="0" marL="0">
+            <a:pPr marL="0" indent="0">
               <a:lnSpc>
                 <a:spcPts val="1700"/>
               </a:lnSpc>
@@ -8284,7 +8096,7 @@
           <a:bodyPr wrap="square" rtlCol="0" anchor="ctr"/>
           <a:lstStyle/>
           <a:p>
-            <a:pPr indent="0" marL="0">
+            <a:pPr marL="0" indent="0">
               <a:buNone/>
             </a:pPr>
             <a:r>
@@ -8323,7 +8135,7 @@
           <a:bodyPr wrap="square" rtlCol="0" anchor="ctr"/>
           <a:lstStyle/>
           <a:p>
-            <a:pPr indent="0" marL="0">
+            <a:pPr marL="0" indent="0">
               <a:buNone/>
             </a:pPr>
             <a:r>
@@ -8362,7 +8174,7 @@
           <a:bodyPr wrap="square" rtlCol="0" anchor="ctr"/>
           <a:lstStyle/>
           <a:p>
-            <a:pPr indent="0" marL="0">
+            <a:pPr marL="0" indent="0">
               <a:lnSpc>
                 <a:spcPts val="1700"/>
               </a:lnSpc>
@@ -8431,7 +8243,7 @@
           <a:bodyPr wrap="square" rtlCol="0" anchor="ctr"/>
           <a:lstStyle/>
           <a:p>
-            <a:pPr indent="0" marL="0">
+            <a:pPr marL="0" indent="0">
               <a:buNone/>
             </a:pPr>
             <a:r>
@@ -8470,7 +8282,7 @@
           <a:bodyPr wrap="square" rtlCol="0" anchor="ctr"/>
           <a:lstStyle/>
           <a:p>
-            <a:pPr indent="0" marL="0">
+            <a:pPr marL="0" indent="0">
               <a:buNone/>
             </a:pPr>
             <a:r>
@@ -8509,7 +8321,7 @@
           <a:bodyPr wrap="square" rtlCol="0" anchor="ctr"/>
           <a:lstStyle/>
           <a:p>
-            <a:pPr indent="0" marL="0">
+            <a:pPr marL="0" indent="0">
               <a:lnSpc>
                 <a:spcPts val="1700"/>
               </a:lnSpc>
@@ -8578,7 +8390,7 @@
           <a:bodyPr wrap="square" rtlCol="0" anchor="ctr"/>
           <a:lstStyle/>
           <a:p>
-            <a:pPr indent="0" marL="0">
+            <a:pPr marL="0" indent="0">
               <a:buNone/>
             </a:pPr>
             <a:r>
@@ -8617,7 +8429,7 @@
           <a:bodyPr wrap="square" rtlCol="0" anchor="ctr"/>
           <a:lstStyle/>
           <a:p>
-            <a:pPr indent="0" marL="0">
+            <a:pPr marL="0" indent="0">
               <a:buNone/>
             </a:pPr>
             <a:r>
@@ -8656,7 +8468,7 @@
           <a:bodyPr wrap="square" rtlCol="0" anchor="ctr"/>
           <a:lstStyle/>
           <a:p>
-            <a:pPr indent="0" marL="0">
+            <a:pPr marL="0" indent="0">
               <a:lnSpc>
                 <a:spcPts val="1700"/>
               </a:lnSpc>
@@ -8725,7 +8537,7 @@
           <a:bodyPr wrap="square" rtlCol="0" anchor="ctr"/>
           <a:lstStyle/>
           <a:p>
-            <a:pPr indent="0" marL="0">
+            <a:pPr marL="0" indent="0">
               <a:buNone/>
             </a:pPr>
             <a:r>
@@ -8764,7 +8576,7 @@
           <a:bodyPr wrap="square" rtlCol="0" anchor="ctr"/>
           <a:lstStyle/>
           <a:p>
-            <a:pPr indent="0" marL="0">
+            <a:pPr marL="0" indent="0">
               <a:buNone/>
             </a:pPr>
             <a:r>
@@ -8803,7 +8615,7 @@
           <a:bodyPr wrap="square" rtlCol="0" anchor="ctr"/>
           <a:lstStyle/>
           <a:p>
-            <a:pPr indent="0" marL="0">
+            <a:pPr marL="0" indent="0">
               <a:lnSpc>
                 <a:spcPts val="1700"/>
               </a:lnSpc>
@@ -8872,7 +8684,7 @@
           <a:bodyPr wrap="square" rtlCol="0" anchor="ctr"/>
           <a:lstStyle/>
           <a:p>
-            <a:pPr indent="0" marL="0">
+            <a:pPr marL="0" indent="0">
               <a:buNone/>
             </a:pPr>
             <a:r>
@@ -8911,7 +8723,7 @@
           <a:bodyPr wrap="square" rtlCol="0" anchor="ctr"/>
           <a:lstStyle/>
           <a:p>
-            <a:pPr indent="0" marL="0">
+            <a:pPr marL="0" indent="0">
               <a:lnSpc>
                 <a:spcPts val="2200"/>
               </a:lnSpc>
@@ -8929,12 +8741,6 @@
               <a:t>I don't prompt Claude anymore. I have loops running that prompt Claude.
 </a:t>
             </a:r>
-            <a:pPr indent="0" marL="0">
-              <a:lnSpc>
-                <a:spcPts val="2200"/>
-              </a:lnSpc>
-              <a:buNone/>
-            </a:pPr>
             <a:r>
               <a:rPr lang="en-US" sz="1150" dirty="0">
                 <a:solidFill>
@@ -8971,7 +8777,7 @@
           <a:bodyPr wrap="square" rtlCol="0" anchor="ctr"/>
           <a:lstStyle/>
           <a:p>
-            <a:pPr indent="0" marL="0">
+            <a:pPr marL="0" indent="0">
               <a:buNone/>
             </a:pPr>
             <a:r>
@@ -9010,7 +8816,7 @@
           <a:bodyPr wrap="square" rtlCol="0" anchor="ctr"/>
           <a:lstStyle/>
           <a:p>
-            <a:pPr algn="r" indent="0" marL="0">
+            <a:pPr marL="0" indent="0" algn="r">
               <a:buNone/>
             </a:pPr>
             <a:r>
@@ -9044,6 +8850,7 @@
         <a:solidFill>
           <a:srgbClr val="FFFFFF"/>
         </a:solidFill>
+        <a:effectLst/>
       </p:bgPr>
     </p:bg>
     <p:spTree>
@@ -9081,11 +8888,11 @@
           <a:bodyPr wrap="square" rtlCol="0" anchor="ctr"/>
           <a:lstStyle/>
           <a:p>
-            <a:pPr indent="0" marL="0">
-              <a:buNone/>
-            </a:pPr>
-            <a:r>
-              <a:rPr lang="en-US" sz="1200" b="1" spc="200" kern="0" dirty="0">
+            <a:pPr marL="0" indent="0">
+              <a:buNone/>
+            </a:pPr>
+            <a:r>
+              <a:rPr lang="en-US" sz="1200" b="1" kern="0" spc="200" dirty="0">
                 <a:solidFill>
                   <a:srgbClr val="F96167"/>
                 </a:solidFill>
@@ -9120,7 +8927,7 @@
           <a:bodyPr wrap="square" rtlCol="0" anchor="ctr"/>
           <a:lstStyle/>
           <a:p>
-            <a:pPr indent="0" marL="0">
+            <a:pPr marL="0" indent="0">
               <a:buNone/>
             </a:pPr>
             <a:r>
@@ -9212,7 +9019,7 @@
       </p:sp>
       <p:graphicFrame>
         <p:nvGraphicFramePr>
-          <p:cNvPr id="4" name="Table 0"/>
+          <p:cNvPr id="7" name="Table 0"/>
           <p:cNvGraphicFramePr>
             <a:graphicFrameLocks noGrp="1"/>
           </p:cNvGraphicFramePr>
@@ -9226,17 +9033,41 @@
         </p:nvGraphicFramePr>
         <p:xfrm>
           <a:off x="548640" y="1783080"/>
-          <a:ext cx="11091672" cy="914400"/>
+          <a:ext cx="11091672" cy="2834640"/>
         </p:xfrm>
         <a:graphic>
           <a:graphicData uri="http://schemas.openxmlformats.org/drawingml/2006/table">
             <a:tbl>
               <a:tblPr/>
               <a:tblGrid>
-                <a:gridCol w="2011680"/>
-                <a:gridCol w="3026664"/>
-                <a:gridCol w="3026664"/>
-                <a:gridCol w="3026664"/>
+                <a:gridCol w="2011680">
+                  <a:extLst>
+                    <a:ext uri="{9D8B030D-6E8A-4147-A177-3AD203B41FA5}">
+                      <a16:colId xmlns:a16="http://schemas.microsoft.com/office/drawing/2014/main" val="20000"/>
+                    </a:ext>
+                  </a:extLst>
+                </a:gridCol>
+                <a:gridCol w="3026664">
+                  <a:extLst>
+                    <a:ext uri="{9D8B030D-6E8A-4147-A177-3AD203B41FA5}">
+                      <a16:colId xmlns:a16="http://schemas.microsoft.com/office/drawing/2014/main" val="20001"/>
+                    </a:ext>
+                  </a:extLst>
+                </a:gridCol>
+                <a:gridCol w="3026664">
+                  <a:extLst>
+                    <a:ext uri="{9D8B030D-6E8A-4147-A177-3AD203B41FA5}">
+                      <a16:colId xmlns:a16="http://schemas.microsoft.com/office/drawing/2014/main" val="20002"/>
+                    </a:ext>
+                  </a:extLst>
+                </a:gridCol>
+                <a:gridCol w="3026664">
+                  <a:extLst>
+                    <a:ext uri="{9D8B030D-6E8A-4147-A177-3AD203B41FA5}">
+                      <a16:colId xmlns:a16="http://schemas.microsoft.com/office/drawing/2014/main" val="20003"/>
+                    </a:ext>
+                  </a:extLst>
+                </a:gridCol>
               </a:tblGrid>
               <a:tr h="566928">
                 <a:tc>
@@ -9244,7 +9075,7 @@
                     <a:bodyPr/>
                     <a:lstStyle/>
                     <a:p>
-                      <a:pPr algn="l" indent="0" marL="0">
+                      <a:pPr marL="0" indent="0" algn="l">
                         <a:buNone/>
                       </a:pPr>
                       <a:endParaRPr lang="en-US" sz="1300" dirty="0">
@@ -9254,7 +9085,7 @@
                       </a:endParaRPr>
                     </a:p>
                   </a:txBody>
-                  <a:tcPr marL="91440" marR="91440" marT="45720" marB="45720" anchor="ctr">
+                  <a:tcPr anchor="ctr">
                     <a:lnL w="12700" cap="flat" cmpd="sng" algn="ctr">
                       <a:solidFill>
                         <a:srgbClr val="D8E2F5"/>
@@ -9298,7 +9129,7 @@
                     <a:bodyPr/>
                     <a:lstStyle/>
                     <a:p>
-                      <a:pPr algn="l" indent="0" marL="0">
+                      <a:pPr marL="0" indent="0" algn="l">
                         <a:buNone/>
                       </a:pPr>
                       <a:r>
@@ -9319,7 +9150,7 @@
                       </a:endParaRPr>
                     </a:p>
                   </a:txBody>
-                  <a:tcPr marL="91440" marR="91440" marT="45720" marB="45720" anchor="ctr">
+                  <a:tcPr anchor="ctr">
                     <a:lnL w="12700" cap="flat" cmpd="sng" algn="ctr">
                       <a:solidFill>
                         <a:srgbClr val="D8E2F5"/>
@@ -9366,7 +9197,7 @@
                     <a:bodyPr/>
                     <a:lstStyle/>
                     <a:p>
-                      <a:pPr algn="l" indent="0" marL="0">
+                      <a:pPr marL="0" indent="0" algn="l">
                         <a:buNone/>
                       </a:pPr>
                       <a:r>
@@ -9387,7 +9218,7 @@
                       </a:endParaRPr>
                     </a:p>
                   </a:txBody>
-                  <a:tcPr marL="91440" marR="91440" marT="45720" marB="45720" anchor="ctr">
+                  <a:tcPr anchor="ctr">
                     <a:lnL w="12700" cap="flat" cmpd="sng" algn="ctr">
                       <a:solidFill>
                         <a:srgbClr val="D8E2F5"/>
@@ -9434,7 +9265,7 @@
                     <a:bodyPr/>
                     <a:lstStyle/>
                     <a:p>
-                      <a:pPr algn="l" indent="0" marL="0">
+                      <a:pPr marL="0" indent="0" algn="l">
                         <a:buNone/>
                       </a:pPr>
                       <a:r>
@@ -9455,7 +9286,7 @@
                       </a:endParaRPr>
                     </a:p>
                   </a:txBody>
-                  <a:tcPr marL="91440" marR="91440" marT="45720" marB="45720" anchor="ctr">
+                  <a:tcPr anchor="ctr">
                     <a:lnL w="12700" cap="flat" cmpd="sng" algn="ctr">
                       <a:solidFill>
                         <a:srgbClr val="D8E2F5"/>
@@ -9497,6 +9328,11 @@
                     </a:solidFill>
                   </a:tcPr>
                 </a:tc>
+                <a:extLst>
+                  <a:ext uri="{0D108BD9-81ED-4DB2-BD59-A6C34878D82A}">
+                    <a16:rowId xmlns:a16="http://schemas.microsoft.com/office/drawing/2014/main" val="10000"/>
+                  </a:ext>
+                </a:extLst>
               </a:tr>
               <a:tr h="566928">
                 <a:tc>
@@ -9504,7 +9340,7 @@
                     <a:bodyPr/>
                     <a:lstStyle/>
                     <a:p>
-                      <a:pPr algn="l" indent="0" marL="0">
+                      <a:pPr marL="0" indent="0" algn="l">
                         <a:buNone/>
                       </a:pPr>
                       <a:r>
@@ -9525,7 +9361,7 @@
                       </a:endParaRPr>
                     </a:p>
                   </a:txBody>
-                  <a:tcPr marL="91440" marR="91440" marT="45720" marB="45720" anchor="ctr">
+                  <a:tcPr anchor="ctr">
                     <a:lnL w="12700" cap="flat" cmpd="sng" algn="ctr">
                       <a:solidFill>
                         <a:srgbClr val="D8E2F5"/>
@@ -9572,7 +9408,7 @@
                     <a:bodyPr/>
                     <a:lstStyle/>
                     <a:p>
-                      <a:pPr algn="l" indent="0" marL="0">
+                      <a:pPr marL="0" indent="0" algn="l">
                         <a:buNone/>
                       </a:pPr>
                       <a:r>
@@ -9593,7 +9429,7 @@
                       </a:endParaRPr>
                     </a:p>
                   </a:txBody>
-                  <a:tcPr marL="91440" marR="91440" marT="45720" marB="45720" anchor="ctr">
+                  <a:tcPr anchor="ctr">
                     <a:lnL w="12700" cap="flat" cmpd="sng" algn="ctr">
                       <a:solidFill>
                         <a:srgbClr val="D8E2F5"/>
@@ -9640,7 +9476,7 @@
                     <a:bodyPr/>
                     <a:lstStyle/>
                     <a:p>
-                      <a:pPr algn="l" indent="0" marL="0">
+                      <a:pPr marL="0" indent="0" algn="l">
                         <a:buNone/>
                       </a:pPr>
                       <a:r>
@@ -9661,7 +9497,7 @@
                       </a:endParaRPr>
                     </a:p>
                   </a:txBody>
-                  <a:tcPr marL="91440" marR="91440" marT="45720" marB="45720" anchor="ctr">
+                  <a:tcPr anchor="ctr">
                     <a:lnL w="12700" cap="flat" cmpd="sng" algn="ctr">
                       <a:solidFill>
                         <a:srgbClr val="D8E2F5"/>
@@ -9708,7 +9544,7 @@
                     <a:bodyPr/>
                     <a:lstStyle/>
                     <a:p>
-                      <a:pPr algn="l" indent="0" marL="0">
+                      <a:pPr marL="0" indent="0" algn="l">
                         <a:buNone/>
                       </a:pPr>
                       <a:r>
@@ -9729,7 +9565,7 @@
                       </a:endParaRPr>
                     </a:p>
                   </a:txBody>
-                  <a:tcPr marL="91440" marR="91440" marT="45720" marB="45720" anchor="ctr">
+                  <a:tcPr anchor="ctr">
                     <a:lnL w="12700" cap="flat" cmpd="sng" algn="ctr">
                       <a:solidFill>
                         <a:srgbClr val="D8E2F5"/>
@@ -9771,6 +9607,11 @@
                     </a:solidFill>
                   </a:tcPr>
                 </a:tc>
+                <a:extLst>
+                  <a:ext uri="{0D108BD9-81ED-4DB2-BD59-A6C34878D82A}">
+                    <a16:rowId xmlns:a16="http://schemas.microsoft.com/office/drawing/2014/main" val="10001"/>
+                  </a:ext>
+                </a:extLst>
               </a:tr>
               <a:tr h="566928">
                 <a:tc>
@@ -9778,7 +9619,7 @@
                     <a:bodyPr/>
                     <a:lstStyle/>
                     <a:p>
-                      <a:pPr algn="l" indent="0" marL="0">
+                      <a:pPr marL="0" indent="0" algn="l">
                         <a:buNone/>
                       </a:pPr>
                       <a:r>
@@ -9799,7 +9640,7 @@
                       </a:endParaRPr>
                     </a:p>
                   </a:txBody>
-                  <a:tcPr marL="91440" marR="91440" marT="45720" marB="45720" anchor="ctr">
+                  <a:tcPr anchor="ctr">
                     <a:lnL w="12700" cap="flat" cmpd="sng" algn="ctr">
                       <a:solidFill>
                         <a:srgbClr val="D8E2F5"/>
@@ -9846,7 +9687,7 @@
                     <a:bodyPr/>
                     <a:lstStyle/>
                     <a:p>
-                      <a:pPr algn="l" indent="0" marL="0">
+                      <a:pPr marL="0" indent="0" algn="l">
                         <a:buNone/>
                       </a:pPr>
                       <a:r>
@@ -9867,7 +9708,7 @@
                       </a:endParaRPr>
                     </a:p>
                   </a:txBody>
-                  <a:tcPr marL="91440" marR="91440" marT="45720" marB="45720" anchor="ctr">
+                  <a:tcPr anchor="ctr">
                     <a:lnL w="12700" cap="flat" cmpd="sng" algn="ctr">
                       <a:solidFill>
                         <a:srgbClr val="D8E2F5"/>
@@ -9914,7 +9755,7 @@
                     <a:bodyPr/>
                     <a:lstStyle/>
                     <a:p>
-                      <a:pPr algn="l" indent="0" marL="0">
+                      <a:pPr marL="0" indent="0" algn="l">
                         <a:buNone/>
                       </a:pPr>
                       <a:r>
@@ -9935,7 +9776,7 @@
                       </a:endParaRPr>
                     </a:p>
                   </a:txBody>
-                  <a:tcPr marL="91440" marR="91440" marT="45720" marB="45720" anchor="ctr">
+                  <a:tcPr anchor="ctr">
                     <a:lnL w="12700" cap="flat" cmpd="sng" algn="ctr">
                       <a:solidFill>
                         <a:srgbClr val="D8E2F5"/>
@@ -9982,7 +9823,7 @@
                     <a:bodyPr/>
                     <a:lstStyle/>
                     <a:p>
-                      <a:pPr algn="l" indent="0" marL="0">
+                      <a:pPr marL="0" indent="0" algn="l">
                         <a:buNone/>
                       </a:pPr>
                       <a:r>
@@ -10003,7 +9844,7 @@
                       </a:endParaRPr>
                     </a:p>
                   </a:txBody>
-                  <a:tcPr marL="91440" marR="91440" marT="45720" marB="45720" anchor="ctr">
+                  <a:tcPr anchor="ctr">
                     <a:lnL w="12700" cap="flat" cmpd="sng" algn="ctr">
                       <a:solidFill>
                         <a:srgbClr val="D8E2F5"/>
@@ -10045,6 +9886,11 @@
                     </a:solidFill>
                   </a:tcPr>
                 </a:tc>
+                <a:extLst>
+                  <a:ext uri="{0D108BD9-81ED-4DB2-BD59-A6C34878D82A}">
+                    <a16:rowId xmlns:a16="http://schemas.microsoft.com/office/drawing/2014/main" val="10002"/>
+                  </a:ext>
+                </a:extLst>
               </a:tr>
               <a:tr h="566928">
                 <a:tc>
@@ -10052,7 +9898,7 @@
                     <a:bodyPr/>
                     <a:lstStyle/>
                     <a:p>
-                      <a:pPr algn="l" indent="0" marL="0">
+                      <a:pPr marL="0" indent="0" algn="l">
                         <a:buNone/>
                       </a:pPr>
                       <a:r>
@@ -10073,7 +9919,7 @@
                       </a:endParaRPr>
                     </a:p>
                   </a:txBody>
-                  <a:tcPr marL="91440" marR="91440" marT="45720" marB="45720" anchor="ctr">
+                  <a:tcPr anchor="ctr">
                     <a:lnL w="12700" cap="flat" cmpd="sng" algn="ctr">
                       <a:solidFill>
                         <a:srgbClr val="D8E2F5"/>
@@ -10120,7 +9966,7 @@
                     <a:bodyPr/>
                     <a:lstStyle/>
                     <a:p>
-                      <a:pPr algn="l" indent="0" marL="0">
+                      <a:pPr marL="0" indent="0" algn="l">
                         <a:buNone/>
                       </a:pPr>
                       <a:r>
@@ -10141,7 +9987,7 @@
                       </a:endParaRPr>
                     </a:p>
                   </a:txBody>
-                  <a:tcPr marL="91440" marR="91440" marT="45720" marB="45720" anchor="ctr">
+                  <a:tcPr anchor="ctr">
                     <a:lnL w="12700" cap="flat" cmpd="sng" algn="ctr">
                       <a:solidFill>
                         <a:srgbClr val="D8E2F5"/>
@@ -10188,7 +10034,7 @@
                     <a:bodyPr/>
                     <a:lstStyle/>
                     <a:p>
-                      <a:pPr algn="l" indent="0" marL="0">
+                      <a:pPr marL="0" indent="0" algn="l">
                         <a:buNone/>
                       </a:pPr>
                       <a:r>
@@ -10209,7 +10055,7 @@
                       </a:endParaRPr>
                     </a:p>
                   </a:txBody>
-                  <a:tcPr marL="91440" marR="91440" marT="45720" marB="45720" anchor="ctr">
+                  <a:tcPr anchor="ctr">
                     <a:lnL w="12700" cap="flat" cmpd="sng" algn="ctr">
                       <a:solidFill>
                         <a:srgbClr val="D8E2F5"/>
@@ -10256,7 +10102,7 @@
                     <a:bodyPr/>
                     <a:lstStyle/>
                     <a:p>
-                      <a:pPr algn="l" indent="0" marL="0">
+                      <a:pPr marL="0" indent="0" algn="l">
                         <a:buNone/>
                       </a:pPr>
                       <a:r>
@@ -10277,7 +10123,7 @@
                       </a:endParaRPr>
                     </a:p>
                   </a:txBody>
-                  <a:tcPr marL="91440" marR="91440" marT="45720" marB="45720" anchor="ctr">
+                  <a:tcPr anchor="ctr">
                     <a:lnL w="12700" cap="flat" cmpd="sng" algn="ctr">
                       <a:solidFill>
                         <a:srgbClr val="D8E2F5"/>
@@ -10319,6 +10165,11 @@
                     </a:solidFill>
                   </a:tcPr>
                 </a:tc>
+                <a:extLst>
+                  <a:ext uri="{0D108BD9-81ED-4DB2-BD59-A6C34878D82A}">
+                    <a16:rowId xmlns:a16="http://schemas.microsoft.com/office/drawing/2014/main" val="10003"/>
+                  </a:ext>
+                </a:extLst>
               </a:tr>
               <a:tr h="566928">
                 <a:tc>
@@ -10326,7 +10177,7 @@
                     <a:bodyPr/>
                     <a:lstStyle/>
                     <a:p>
-                      <a:pPr algn="l" indent="0" marL="0">
+                      <a:pPr marL="0" indent="0" algn="l">
                         <a:buNone/>
                       </a:pPr>
                       <a:r>
@@ -10347,7 +10198,7 @@
                       </a:endParaRPr>
                     </a:p>
                   </a:txBody>
-                  <a:tcPr marL="91440" marR="91440" marT="45720" marB="45720" anchor="ctr">
+                  <a:tcPr anchor="ctr">
                     <a:lnL w="12700" cap="flat" cmpd="sng" algn="ctr">
                       <a:solidFill>
                         <a:srgbClr val="D8E2F5"/>
@@ -10394,7 +10245,7 @@
                     <a:bodyPr/>
                     <a:lstStyle/>
                     <a:p>
-                      <a:pPr algn="l" indent="0" marL="0">
+                      <a:pPr marL="0" indent="0" algn="l">
                         <a:buNone/>
                       </a:pPr>
                       <a:r>
@@ -10415,7 +10266,7 @@
                       </a:endParaRPr>
                     </a:p>
                   </a:txBody>
-                  <a:tcPr marL="91440" marR="91440" marT="45720" marB="45720" anchor="ctr">
+                  <a:tcPr anchor="ctr">
                     <a:lnL w="12700" cap="flat" cmpd="sng" algn="ctr">
                       <a:solidFill>
                         <a:srgbClr val="D8E2F5"/>
@@ -10462,7 +10313,7 @@
                     <a:bodyPr/>
                     <a:lstStyle/>
                     <a:p>
-                      <a:pPr algn="l" indent="0" marL="0">
+                      <a:pPr marL="0" indent="0" algn="l">
                         <a:buNone/>
                       </a:pPr>
                       <a:r>
@@ -10483,7 +10334,7 @@
                       </a:endParaRPr>
                     </a:p>
                   </a:txBody>
-                  <a:tcPr marL="91440" marR="91440" marT="45720" marB="45720" anchor="ctr">
+                  <a:tcPr anchor="ctr">
                     <a:lnL w="12700" cap="flat" cmpd="sng" algn="ctr">
                       <a:solidFill>
                         <a:srgbClr val="D8E2F5"/>
@@ -10530,7 +10381,7 @@
                     <a:bodyPr/>
                     <a:lstStyle/>
                     <a:p>
-                      <a:pPr algn="l" indent="0" marL="0">
+                      <a:pPr marL="0" indent="0" algn="l">
                         <a:buNone/>
                       </a:pPr>
                       <a:r>
@@ -10551,7 +10402,7 @@
                       </a:endParaRPr>
                     </a:p>
                   </a:txBody>
-                  <a:tcPr marL="91440" marR="91440" marT="45720" marB="45720" anchor="ctr">
+                  <a:tcPr anchor="ctr">
                     <a:lnL w="12700" cap="flat" cmpd="sng" algn="ctr">
                       <a:solidFill>
                         <a:srgbClr val="D8E2F5"/>
@@ -10593,6 +10444,11 @@
                     </a:solidFill>
                   </a:tcPr>
                 </a:tc>
+                <a:extLst>
+                  <a:ext uri="{0D108BD9-81ED-4DB2-BD59-A6C34878D82A}">
+                    <a16:rowId xmlns:a16="http://schemas.microsoft.com/office/drawing/2014/main" val="10004"/>
+                  </a:ext>
+                </a:extLst>
               </a:tr>
             </a:tbl>
           </a:graphicData>
@@ -10661,7 +10517,7 @@
           <a:bodyPr wrap="square" rtlCol="0" anchor="ctr"/>
           <a:lstStyle/>
           <a:p>
-            <a:pPr algn="ctr" indent="0" marL="0">
+            <a:pPr marL="0" indent="0" algn="ctr">
               <a:buNone/>
             </a:pPr>
             <a:r>
@@ -10700,7 +10556,7 @@
           <a:bodyPr wrap="square" rtlCol="0" anchor="ctr"/>
           <a:lstStyle/>
           <a:p>
-            <a:pPr indent="0" marL="0">
+            <a:pPr marL="0" indent="0">
               <a:lnSpc>
                 <a:spcPts val="2100"/>
               </a:lnSpc>
@@ -10717,12 +10573,6 @@
               </a:rPr>
               <a:t>一把判断刀：</a:t>
             </a:r>
-            <a:pPr indent="0" marL="0">
-              <a:lnSpc>
-                <a:spcPts val="2100"/>
-              </a:lnSpc>
-              <a:buNone/>
-            </a:pPr>
             <a:r>
               <a:rPr lang="en-US" sz="1450" dirty="0">
                 <a:solidFill>
@@ -10759,7 +10609,7 @@
           <a:bodyPr wrap="square" rtlCol="0" anchor="ctr"/>
           <a:lstStyle/>
           <a:p>
-            <a:pPr indent="0" marL="0">
+            <a:pPr marL="0" indent="0">
               <a:buNone/>
             </a:pPr>
             <a:r>
@@ -10798,7 +10648,7 @@
           <a:bodyPr wrap="square" rtlCol="0" anchor="ctr"/>
           <a:lstStyle/>
           <a:p>
-            <a:pPr algn="r" indent="0" marL="0">
+            <a:pPr marL="0" indent="0" algn="r">
               <a:buNone/>
             </a:pPr>
             <a:r>
@@ -10832,6 +10682,7 @@
         <a:solidFill>
           <a:srgbClr val="FFFFFF"/>
         </a:solidFill>
+        <a:effectLst/>
       </p:bgPr>
     </p:bg>
     <p:spTree>
@@ -10869,11 +10720,11 @@
           <a:bodyPr wrap="square" rtlCol="0" anchor="ctr"/>
           <a:lstStyle/>
           <a:p>
-            <a:pPr indent="0" marL="0">
-              <a:buNone/>
-            </a:pPr>
-            <a:r>
-              <a:rPr lang="en-US" sz="1200" b="1" spc="200" kern="0" dirty="0">
+            <a:pPr marL="0" indent="0">
+              <a:buNone/>
+            </a:pPr>
+            <a:r>
+              <a:rPr lang="en-US" sz="1200" b="1" kern="0" spc="200" dirty="0">
                 <a:solidFill>
                   <a:srgbClr val="F96167"/>
                 </a:solidFill>
@@ -10908,7 +10759,7 @@
           <a:bodyPr wrap="square" rtlCol="0" anchor="ctr"/>
           <a:lstStyle/>
           <a:p>
-            <a:pPr indent="0" marL="0">
+            <a:pPr marL="0" indent="0">
               <a:buNone/>
             </a:pPr>
             <a:r>
@@ -11006,7 +10857,7 @@
         </p:nvSpPr>
         <p:spPr>
           <a:xfrm>
-            <a:off x="548640" y="1783080"/>
+            <a:off x="548513" y="1755648"/>
             <a:ext cx="5349240" cy="3246120"/>
           </a:xfrm>
           <a:prstGeom prst="roundRect">
@@ -11046,7 +10897,7 @@
           <a:bodyPr wrap="square" rtlCol="0" anchor="ctr"/>
           <a:lstStyle/>
           <a:p>
-            <a:pPr indent="0" marL="0">
+            <a:pPr marL="0" indent="0">
               <a:buNone/>
             </a:pPr>
             <a:r>
@@ -11085,7 +10936,7 @@
           <a:bodyPr wrap="square" rtlCol="0" anchor="ctr"/>
           <a:lstStyle/>
           <a:p>
-            <a:pPr indent="0" marL="0">
+            <a:pPr marL="0" indent="0">
               <a:buNone/>
             </a:pPr>
             <a:r>
@@ -11124,7 +10975,7 @@
           <a:bodyPr wrap="square" rtlCol="0" anchor="ctr"/>
           <a:lstStyle/>
           <a:p>
-            <a:pPr indent="0" marL="0">
+            <a:pPr marL="0" indent="0">
               <a:lnSpc>
                 <a:spcPts val="2100"/>
               </a:lnSpc>
@@ -11144,7 +10995,7 @@
             <a:endParaRPr lang="en-US" sz="1350" dirty="0"/>
           </a:p>
           <a:p>
-            <a:pPr indent="0" marL="0">
+            <a:pPr marL="0" indent="0">
               <a:lnSpc>
                 <a:spcPts val="2100"/>
               </a:lnSpc>
@@ -11153,7 +11004,7 @@
             <a:endParaRPr lang="en-US" sz="1350" dirty="0"/>
           </a:p>
           <a:p>
-            <a:pPr indent="0" marL="0">
+            <a:pPr marL="0" indent="0">
               <a:lnSpc>
                 <a:spcPts val="2100"/>
               </a:lnSpc>
@@ -11217,7 +11068,7 @@
           <a:bodyPr wrap="square" rtlCol="0" anchor="ctr"/>
           <a:lstStyle/>
           <a:p>
-            <a:pPr indent="0" marL="0">
+            <a:pPr marL="0" indent="0">
               <a:buNone/>
             </a:pPr>
             <a:r>
@@ -11256,7 +11107,7 @@
           <a:bodyPr wrap="square" rtlCol="0" anchor="ctr"/>
           <a:lstStyle/>
           <a:p>
-            <a:pPr indent="0" marL="0">
+            <a:pPr marL="0" indent="0">
               <a:buNone/>
             </a:pPr>
             <a:r>
@@ -11295,7 +11146,7 @@
           <a:bodyPr wrap="square" rtlCol="0" anchor="ctr"/>
           <a:lstStyle/>
           <a:p>
-            <a:pPr indent="0" marL="0">
+            <a:pPr marL="0" indent="0">
               <a:lnSpc>
                 <a:spcPts val="2100"/>
               </a:lnSpc>
@@ -11315,7 +11166,7 @@
             <a:endParaRPr lang="en-US" sz="1350" dirty="0"/>
           </a:p>
           <a:p>
-            <a:pPr indent="0" marL="0">
+            <a:pPr marL="0" indent="0">
               <a:lnSpc>
                 <a:spcPts val="2100"/>
               </a:lnSpc>
@@ -11324,7 +11175,7 @@
             <a:endParaRPr lang="en-US" sz="1350" dirty="0"/>
           </a:p>
           <a:p>
-            <a:pPr indent="0" marL="0">
+            <a:pPr marL="0" indent="0">
               <a:lnSpc>
                 <a:spcPts val="2100"/>
               </a:lnSpc>
@@ -11393,7 +11244,7 @@
           <a:bodyPr wrap="square" rtlCol="0" anchor="ctr"/>
           <a:lstStyle/>
           <a:p>
-            <a:pPr indent="0" marL="0">
+            <a:pPr marL="0" indent="0">
               <a:buNone/>
             </a:pPr>
             <a:r>
@@ -11407,9 +11258,6 @@
               </a:rPr>
               <a:t>类比：</a:t>
             </a:r>
-            <a:pPr indent="0" marL="0">
-              <a:buNone/>
-            </a:pPr>
             <a:r>
               <a:rPr lang="en-US" sz="1400" dirty="0">
                 <a:solidFill>
@@ -11446,7 +11294,7 @@
           <a:bodyPr wrap="square" rtlCol="0" anchor="ctr"/>
           <a:lstStyle/>
           <a:p>
-            <a:pPr indent="0" marL="0">
+            <a:pPr marL="0" indent="0">
               <a:buNone/>
             </a:pPr>
             <a:r>
@@ -11485,7 +11333,7 @@
           <a:bodyPr wrap="square" rtlCol="0" anchor="ctr"/>
           <a:lstStyle/>
           <a:p>
-            <a:pPr algn="r" indent="0" marL="0">
+            <a:pPr marL="0" indent="0" algn="r">
               <a:buNone/>
             </a:pPr>
             <a:r>
@@ -11519,6 +11367,7 @@
         <a:solidFill>
           <a:srgbClr val="FFFFFF"/>
         </a:solidFill>
+        <a:effectLst/>
       </p:bgPr>
     </p:bg>
     <p:spTree>
@@ -11556,11 +11405,11 @@
           <a:bodyPr wrap="square" rtlCol="0" anchor="ctr"/>
           <a:lstStyle/>
           <a:p>
-            <a:pPr indent="0" marL="0">
-              <a:buNone/>
-            </a:pPr>
-            <a:r>
-              <a:rPr lang="en-US" sz="1200" b="1" spc="200" kern="0" dirty="0">
+            <a:pPr marL="0" indent="0">
+              <a:buNone/>
+            </a:pPr>
+            <a:r>
+              <a:rPr lang="en-US" sz="1200" b="1" kern="0" spc="200" dirty="0">
                 <a:solidFill>
                   <a:srgbClr val="F96167"/>
                 </a:solidFill>
@@ -11595,7 +11444,7 @@
           <a:bodyPr wrap="square" rtlCol="0" anchor="ctr"/>
           <a:lstStyle/>
           <a:p>
-            <a:pPr indent="0" marL="0">
+            <a:pPr marL="0" indent="0">
               <a:buNone/>
             </a:pPr>
             <a:r>
@@ -11706,7 +11555,7 @@
           <a:bodyPr wrap="square" rtlCol="0" anchor="ctr"/>
           <a:lstStyle/>
           <a:p>
-            <a:pPr indent="0" marL="0">
+            <a:pPr marL="0" indent="0">
               <a:buNone/>
             </a:pPr>
             <a:r>
@@ -11720,9 +11569,6 @@
               </a:rPr>
               <a:t>Loop = </a:t>
             </a:r>
-            <a:pPr indent="0" marL="0">
-              <a:buNone/>
-            </a:pPr>
             <a:r>
               <a:rPr lang="en-US" sz="2400" b="1" dirty="0">
                 <a:solidFill>
@@ -11734,9 +11580,6 @@
               </a:rPr>
               <a:t>触发器</a:t>
             </a:r>
-            <a:pPr indent="0" marL="0">
-              <a:buNone/>
-            </a:pPr>
             <a:r>
               <a:rPr lang="en-US" sz="2400" dirty="0">
                 <a:solidFill>
@@ -11748,9 +11591,6 @@
               </a:rPr>
               <a:t> + </a:t>
             </a:r>
-            <a:pPr indent="0" marL="0">
-              <a:buNone/>
-            </a:pPr>
             <a:r>
               <a:rPr lang="en-US" sz="2400" b="1" dirty="0">
                 <a:solidFill>
@@ -11762,9 +11602,6 @@
               </a:rPr>
               <a:t>可验证的目标</a:t>
             </a:r>
-            <a:pPr indent="0" marL="0">
-              <a:buNone/>
-            </a:pPr>
             <a:r>
               <a:rPr lang="en-US" sz="2400" dirty="0">
                 <a:solidFill>
@@ -11776,9 +11613,6 @@
               </a:rPr>
               <a:t> + </a:t>
             </a:r>
-            <a:pPr indent="0" marL="0">
-              <a:buNone/>
-            </a:pPr>
             <a:r>
               <a:rPr lang="en-US" sz="2400" b="1" dirty="0">
                 <a:solidFill>
@@ -11837,7 +11671,7 @@
           <a:bodyPr wrap="square" rtlCol="0" anchor="ctr"/>
           <a:lstStyle/>
           <a:p>
-            <a:pPr algn="ctr" indent="0" marL="0">
+            <a:pPr marL="0" indent="0" algn="ctr">
               <a:buNone/>
             </a:pPr>
             <a:r>
@@ -11876,7 +11710,7 @@
           <a:bodyPr wrap="square" rtlCol="0" anchor="ctr"/>
           <a:lstStyle/>
           <a:p>
-            <a:pPr algn="ctr" indent="0" marL="0">
+            <a:pPr marL="0" indent="0" algn="ctr">
               <a:buNone/>
             </a:pPr>
             <a:r>
@@ -11937,7 +11771,7 @@
           <a:bodyPr wrap="square" rtlCol="0" anchor="ctr"/>
           <a:lstStyle/>
           <a:p>
-            <a:pPr algn="ctr" indent="0" marL="0">
+            <a:pPr marL="0" indent="0" algn="ctr">
               <a:buNone/>
             </a:pPr>
             <a:r>
@@ -11976,7 +11810,7 @@
           <a:bodyPr wrap="square" rtlCol="0" anchor="ctr"/>
           <a:lstStyle/>
           <a:p>
-            <a:pPr algn="ctr" indent="0" marL="0">
+            <a:pPr marL="0" indent="0" algn="ctr">
               <a:buNone/>
             </a:pPr>
             <a:r>
@@ -12037,7 +11871,7 @@
           <a:bodyPr wrap="square" rtlCol="0" anchor="ctr"/>
           <a:lstStyle/>
           <a:p>
-            <a:pPr algn="ctr" indent="0" marL="0">
+            <a:pPr marL="0" indent="0" algn="ctr">
               <a:buNone/>
             </a:pPr>
             <a:r>
@@ -12076,7 +11910,7 @@
           <a:bodyPr wrap="square" rtlCol="0" anchor="ctr"/>
           <a:lstStyle/>
           <a:p>
-            <a:pPr algn="ctr" indent="0" marL="0">
+            <a:pPr marL="0" indent="0" algn="ctr">
               <a:buNone/>
             </a:pPr>
             <a:r>
@@ -12137,7 +11971,7 @@
           <a:bodyPr wrap="square" rtlCol="0" anchor="ctr"/>
           <a:lstStyle/>
           <a:p>
-            <a:pPr algn="ctr" indent="0" marL="0">
+            <a:pPr marL="0" indent="0" algn="ctr">
               <a:buNone/>
             </a:pPr>
             <a:r>
@@ -12176,7 +12010,7 @@
           <a:bodyPr wrap="square" rtlCol="0" anchor="ctr"/>
           <a:lstStyle/>
           <a:p>
-            <a:pPr algn="ctr" indent="0" marL="0">
+            <a:pPr marL="0" indent="0" algn="ctr">
               <a:buNone/>
             </a:pPr>
             <a:r>
@@ -12237,7 +12071,7 @@
           <a:bodyPr wrap="square" rtlCol="0" anchor="ctr"/>
           <a:lstStyle/>
           <a:p>
-            <a:pPr algn="ctr" indent="0" marL="0">
+            <a:pPr marL="0" indent="0" algn="ctr">
               <a:buNone/>
             </a:pPr>
             <a:r>
@@ -12276,7 +12110,7 @@
           <a:bodyPr wrap="square" rtlCol="0" anchor="ctr"/>
           <a:lstStyle/>
           <a:p>
-            <a:pPr algn="ctr" indent="0" marL="0">
+            <a:pPr marL="0" indent="0" algn="ctr">
               <a:buNone/>
             </a:pPr>
             <a:r>
@@ -12362,7 +12196,7 @@
           <a:bodyPr wrap="square" rtlCol="0" anchor="ctr"/>
           <a:lstStyle/>
           <a:p>
-            <a:pPr algn="ctr" indent="0" marL="0">
+            <a:pPr marL="0" indent="0" algn="ctr">
               <a:buNone/>
             </a:pPr>
             <a:r>
@@ -12401,7 +12235,7 @@
           <a:bodyPr wrap="square" rtlCol="0" anchor="ctr"/>
           <a:lstStyle/>
           <a:p>
-            <a:pPr indent="0" marL="0">
+            <a:pPr marL="0" indent="0">
               <a:buNone/>
             </a:pPr>
             <a:r>
@@ -12440,7 +12274,7 @@
           <a:bodyPr wrap="square" rtlCol="0" anchor="ctr"/>
           <a:lstStyle/>
           <a:p>
-            <a:pPr indent="0" marL="0">
+            <a:pPr marL="0" indent="0">
               <a:lnSpc>
                 <a:spcPts val="1800"/>
               </a:lnSpc>
@@ -12460,7 +12294,7 @@
             <a:endParaRPr lang="en-US" sz="1200" dirty="0"/>
           </a:p>
           <a:p>
-            <a:pPr indent="0" marL="0">
+            <a:pPr marL="0" indent="0">
               <a:lnSpc>
                 <a:spcPts val="1800"/>
               </a:lnSpc>
@@ -12549,7 +12383,7 @@
           <a:bodyPr wrap="square" rtlCol="0" anchor="ctr"/>
           <a:lstStyle/>
           <a:p>
-            <a:pPr algn="ctr" indent="0" marL="0">
+            <a:pPr marL="0" indent="0" algn="ctr">
               <a:buNone/>
             </a:pPr>
             <a:r>
@@ -12588,7 +12422,7 @@
           <a:bodyPr wrap="square" rtlCol="0" anchor="ctr"/>
           <a:lstStyle/>
           <a:p>
-            <a:pPr indent="0" marL="0">
+            <a:pPr marL="0" indent="0">
               <a:buNone/>
             </a:pPr>
             <a:r>
@@ -12627,7 +12461,7 @@
           <a:bodyPr wrap="square" rtlCol="0" anchor="ctr"/>
           <a:lstStyle/>
           <a:p>
-            <a:pPr indent="0" marL="0">
+            <a:pPr marL="0" indent="0">
               <a:lnSpc>
                 <a:spcPts val="1800"/>
               </a:lnSpc>
@@ -12647,7 +12481,7 @@
             <a:endParaRPr lang="en-US" sz="1200" dirty="0"/>
           </a:p>
           <a:p>
-            <a:pPr indent="0" marL="0">
+            <a:pPr marL="0" indent="0">
               <a:lnSpc>
                 <a:spcPts val="1800"/>
               </a:lnSpc>
@@ -12667,7 +12501,7 @@
             <a:endParaRPr lang="en-US" sz="1200" dirty="0"/>
           </a:p>
           <a:p>
-            <a:pPr indent="0" marL="0">
+            <a:pPr marL="0" indent="0">
               <a:lnSpc>
                 <a:spcPts val="1800"/>
               </a:lnSpc>
@@ -12756,7 +12590,7 @@
           <a:bodyPr wrap="square" rtlCol="0" anchor="ctr"/>
           <a:lstStyle/>
           <a:p>
-            <a:pPr algn="ctr" indent="0" marL="0">
+            <a:pPr marL="0" indent="0" algn="ctr">
               <a:buNone/>
             </a:pPr>
             <a:r>
@@ -12795,7 +12629,7 @@
           <a:bodyPr wrap="square" rtlCol="0" anchor="ctr"/>
           <a:lstStyle/>
           <a:p>
-            <a:pPr indent="0" marL="0">
+            <a:pPr marL="0" indent="0">
               <a:buNone/>
             </a:pPr>
             <a:r>
@@ -12834,7 +12668,7 @@
           <a:bodyPr wrap="square" rtlCol="0" anchor="ctr"/>
           <a:lstStyle/>
           <a:p>
-            <a:pPr indent="0" marL="0">
+            <a:pPr marL="0" indent="0">
               <a:lnSpc>
                 <a:spcPts val="1800"/>
               </a:lnSpc>
@@ -12876,7 +12710,7 @@
           <a:bodyPr wrap="square" rtlCol="0" anchor="ctr"/>
           <a:lstStyle/>
           <a:p>
-            <a:pPr indent="0" marL="0">
+            <a:pPr marL="0" indent="0">
               <a:buNone/>
             </a:pPr>
             <a:r>
@@ -12915,7 +12749,7 @@
           <a:bodyPr wrap="square" rtlCol="0" anchor="ctr"/>
           <a:lstStyle/>
           <a:p>
-            <a:pPr algn="r" indent="0" marL="0">
+            <a:pPr marL="0" indent="0" algn="r">
               <a:buNone/>
             </a:pPr>
             <a:r>
@@ -12949,6 +12783,7 @@
         <a:solidFill>
           <a:srgbClr val="FFFFFF"/>
         </a:solidFill>
+        <a:effectLst/>
       </p:bgPr>
     </p:bg>
     <p:spTree>
@@ -12986,11 +12821,11 @@
           <a:bodyPr wrap="square" rtlCol="0" anchor="ctr"/>
           <a:lstStyle/>
           <a:p>
-            <a:pPr indent="0" marL="0">
-              <a:buNone/>
-            </a:pPr>
-            <a:r>
-              <a:rPr lang="en-US" sz="1200" b="1" spc="200" kern="0" dirty="0">
+            <a:pPr marL="0" indent="0">
+              <a:buNone/>
+            </a:pPr>
+            <a:r>
+              <a:rPr lang="en-US" sz="1200" b="1" kern="0" spc="200" dirty="0">
                 <a:solidFill>
                   <a:srgbClr val="F96167"/>
                 </a:solidFill>
@@ -13025,7 +12860,7 @@
           <a:bodyPr wrap="square" rtlCol="0" anchor="ctr"/>
           <a:lstStyle/>
           <a:p>
-            <a:pPr indent="0" marL="0">
+            <a:pPr marL="0" indent="0">
               <a:buNone/>
             </a:pPr>
             <a:r>
@@ -13163,7 +12998,7 @@
           <a:bodyPr wrap="square" rtlCol="0" anchor="ctr"/>
           <a:lstStyle/>
           <a:p>
-            <a:pPr indent="0" marL="0">
+            <a:pPr marL="0" indent="0">
               <a:buNone/>
             </a:pPr>
             <a:r>
@@ -13199,7 +13034,7 @@
           <a:bodyPr wrap="square" rtlCol="0" anchor="ctr"/>
           <a:lstStyle/>
           <a:p>
-            <a:pPr indent="0" marL="0">
+            <a:pPr marL="0" indent="0">
               <a:buNone/>
             </a:pPr>
             <a:r>
@@ -13238,7 +13073,7 @@
           <a:bodyPr wrap="square" rtlCol="0" anchor="ctr"/>
           <a:lstStyle/>
           <a:p>
-            <a:pPr indent="0" marL="0">
+            <a:pPr marL="0" indent="0">
               <a:lnSpc>
                 <a:spcPts val="1700"/>
               </a:lnSpc>
@@ -13307,7 +13142,7 @@
           <a:bodyPr wrap="square" rtlCol="0" anchor="ctr"/>
           <a:lstStyle/>
           <a:p>
-            <a:pPr indent="0" marL="0">
+            <a:pPr marL="0" indent="0">
               <a:buNone/>
             </a:pPr>
             <a:r>
@@ -13343,7 +13178,7 @@
           <a:bodyPr wrap="square" rtlCol="0" anchor="ctr"/>
           <a:lstStyle/>
           <a:p>
-            <a:pPr indent="0" marL="0">
+            <a:pPr marL="0" indent="0">
               <a:buNone/>
             </a:pPr>
             <a:r>
@@ -13382,7 +13217,7 @@
           <a:bodyPr wrap="square" rtlCol="0" anchor="ctr"/>
           <a:lstStyle/>
           <a:p>
-            <a:pPr indent="0" marL="0">
+            <a:pPr marL="0" indent="0">
               <a:lnSpc>
                 <a:spcPts val="1700"/>
               </a:lnSpc>
@@ -13451,7 +13286,7 @@
           <a:bodyPr wrap="square" rtlCol="0" anchor="ctr"/>
           <a:lstStyle/>
           <a:p>
-            <a:pPr indent="0" marL="0">
+            <a:pPr marL="0" indent="0">
               <a:buNone/>
             </a:pPr>
             <a:r>
@@ -13487,7 +13322,7 @@
           <a:bodyPr wrap="square" rtlCol="0" anchor="ctr"/>
           <a:lstStyle/>
           <a:p>
-            <a:pPr indent="0" marL="0">
+            <a:pPr marL="0" indent="0">
               <a:buNone/>
             </a:pPr>
             <a:r>
@@ -13526,7 +13361,7 @@
           <a:bodyPr wrap="square" rtlCol="0" anchor="ctr"/>
           <a:lstStyle/>
           <a:p>
-            <a:pPr indent="0" marL="0">
+            <a:pPr marL="0" indent="0">
               <a:lnSpc>
                 <a:spcPts val="1700"/>
               </a:lnSpc>
@@ -13595,7 +13430,7 @@
           <a:bodyPr wrap="square" rtlCol="0" anchor="ctr"/>
           <a:lstStyle/>
           <a:p>
-            <a:pPr indent="0" marL="0">
+            <a:pPr marL="0" indent="0">
               <a:buNone/>
             </a:pPr>
             <a:r>
@@ -13631,7 +13466,7 @@
           <a:bodyPr wrap="square" rtlCol="0" anchor="ctr"/>
           <a:lstStyle/>
           <a:p>
-            <a:pPr indent="0" marL="0">
+            <a:pPr marL="0" indent="0">
               <a:buNone/>
             </a:pPr>
             <a:r>
@@ -13670,7 +13505,7 @@
           <a:bodyPr wrap="square" rtlCol="0" anchor="ctr"/>
           <a:lstStyle/>
           <a:p>
-            <a:pPr indent="0" marL="0">
+            <a:pPr marL="0" indent="0">
               <a:lnSpc>
                 <a:spcPts val="1700"/>
               </a:lnSpc>
@@ -13739,7 +13574,7 @@
           <a:bodyPr wrap="square" rtlCol="0" anchor="ctr"/>
           <a:lstStyle/>
           <a:p>
-            <a:pPr indent="0" marL="0">
+            <a:pPr marL="0" indent="0">
               <a:buNone/>
             </a:pPr>
             <a:r>
@@ -13775,7 +13610,7 @@
           <a:bodyPr wrap="square" rtlCol="0" anchor="ctr"/>
           <a:lstStyle/>
           <a:p>
-            <a:pPr indent="0" marL="0">
+            <a:pPr marL="0" indent="0">
               <a:buNone/>
             </a:pPr>
             <a:r>
@@ -13814,7 +13649,7 @@
           <a:bodyPr wrap="square" rtlCol="0" anchor="ctr"/>
           <a:lstStyle/>
           <a:p>
-            <a:pPr indent="0" marL="0">
+            <a:pPr marL="0" indent="0">
               <a:lnSpc>
                 <a:spcPts val="1700"/>
               </a:lnSpc>
@@ -13883,7 +13718,7 @@
           <a:bodyPr wrap="square" rtlCol="0" anchor="ctr"/>
           <a:lstStyle/>
           <a:p>
-            <a:pPr indent="0" marL="0">
+            <a:pPr marL="0" indent="0">
               <a:buNone/>
             </a:pPr>
             <a:r>
@@ -13919,7 +13754,7 @@
           <a:bodyPr wrap="square" rtlCol="0" anchor="ctr"/>
           <a:lstStyle/>
           <a:p>
-            <a:pPr indent="0" marL="0">
+            <a:pPr marL="0" indent="0">
               <a:buNone/>
             </a:pPr>
             <a:r>
@@ -13958,7 +13793,7 @@
           <a:bodyPr wrap="square" rtlCol="0" anchor="ctr"/>
           <a:lstStyle/>
           <a:p>
-            <a:pPr indent="0" marL="0">
+            <a:pPr marL="0" indent="0">
               <a:lnSpc>
                 <a:spcPts val="1700"/>
               </a:lnSpc>
@@ -14000,7 +13835,7 @@
           <a:bodyPr wrap="square" rtlCol="0" anchor="ctr"/>
           <a:lstStyle/>
           <a:p>
-            <a:pPr indent="0" marL="0">
+            <a:pPr marL="0" indent="0">
               <a:buNone/>
             </a:pPr>
             <a:r>
@@ -14039,7 +13874,7 @@
           <a:bodyPr wrap="square" rtlCol="0" anchor="ctr"/>
           <a:lstStyle/>
           <a:p>
-            <a:pPr indent="0" marL="0">
+            <a:pPr marL="0" indent="0">
               <a:buNone/>
             </a:pPr>
             <a:r>
@@ -14078,7 +13913,7 @@
           <a:bodyPr wrap="square" rtlCol="0" anchor="ctr"/>
           <a:lstStyle/>
           <a:p>
-            <a:pPr algn="r" indent="0" marL="0">
+            <a:pPr marL="0" indent="0" algn="r">
               <a:buNone/>
             </a:pPr>
             <a:r>
@@ -14112,6 +13947,7 @@
         <a:solidFill>
           <a:srgbClr val="FFFFFF"/>
         </a:solidFill>
+        <a:effectLst/>
       </p:bgPr>
     </p:bg>
     <p:spTree>
@@ -14149,11 +13985,11 @@
           <a:bodyPr wrap="square" rtlCol="0" anchor="ctr"/>
           <a:lstStyle/>
           <a:p>
-            <a:pPr indent="0" marL="0">
-              <a:buNone/>
-            </a:pPr>
-            <a:r>
-              <a:rPr lang="en-US" sz="1200" b="1" spc="200" kern="0" dirty="0">
+            <a:pPr marL="0" indent="0">
+              <a:buNone/>
+            </a:pPr>
+            <a:r>
+              <a:rPr lang="en-US" sz="1200" b="1" kern="0" spc="200" dirty="0">
                 <a:solidFill>
                   <a:srgbClr val="F96167"/>
                 </a:solidFill>
@@ -14188,7 +14024,7 @@
           <a:bodyPr wrap="square" rtlCol="0" anchor="ctr"/>
           <a:lstStyle/>
           <a:p>
-            <a:pPr indent="0" marL="0">
+            <a:pPr marL="0" indent="0">
               <a:buNone/>
             </a:pPr>
             <a:r>
@@ -14299,7 +14135,7 @@
           <a:bodyPr wrap="square" rtlCol="0" anchor="ctr"/>
           <a:lstStyle/>
           <a:p>
-            <a:pPr indent="0" marL="0">
+            <a:pPr marL="0" indent="0">
               <a:buNone/>
             </a:pPr>
             <a:r>
@@ -14338,7 +14174,7 @@
           <a:bodyPr wrap="square" rtlCol="0" anchor="ctr"/>
           <a:lstStyle/>
           <a:p>
-            <a:pPr indent="0" marL="0">
+            <a:pPr marL="0" indent="0">
               <a:lnSpc>
                 <a:spcPts val="2100"/>
               </a:lnSpc>
@@ -14356,36 +14192,30 @@
               <a:t>犯错的模型和它的盲区共享同一套假设。
 </a:t>
             </a:r>
-            <a:pPr indent="0" marL="0">
+            <a:r>
+              <a:rPr lang="en-US" sz="1350" dirty="0">
+                <a:solidFill>
+                  <a:srgbClr val="23283D"/>
+                </a:solidFill>
+                <a:latin typeface="Microsoft YaHei" pitchFamily="34" charset="0"/>
+                <a:ea typeface="Microsoft YaHei" pitchFamily="34" charset="-122"/>
+                <a:cs typeface="Microsoft YaHei" pitchFamily="34" charset="-120"/>
+              </a:rPr>
+              <a:t>它写代码时遗漏的边界条件，自查时同样会遗漏——因为产生错误的思路，就是它检查时用的思路。</a:t>
+            </a:r>
+            <a:endParaRPr lang="en-US" sz="1550" dirty="0"/>
+          </a:p>
+          <a:p>
+            <a:pPr marL="0" indent="0">
               <a:lnSpc>
                 <a:spcPts val="2100"/>
               </a:lnSpc>
               <a:buNone/>
             </a:pPr>
-            <a:r>
-              <a:rPr lang="en-US" sz="1350" dirty="0">
-                <a:solidFill>
-                  <a:srgbClr val="23283D"/>
-                </a:solidFill>
-                <a:latin typeface="Microsoft YaHei" pitchFamily="34" charset="0"/>
-                <a:ea typeface="Microsoft YaHei" pitchFamily="34" charset="-122"/>
-                <a:cs typeface="Microsoft YaHei" pitchFamily="34" charset="-120"/>
-              </a:rPr>
-              <a:t>它写代码时遗漏的边界条件，自查时同样会遗漏——因为产生错误的思路，就是它检查时用的思路。</a:t>
-            </a:r>
             <a:endParaRPr lang="en-US" sz="1550" dirty="0"/>
           </a:p>
           <a:p>
-            <a:pPr indent="0" marL="0">
-              <a:lnSpc>
-                <a:spcPts val="2100"/>
-              </a:lnSpc>
-              <a:buNone/>
-            </a:pPr>
-            <a:endParaRPr lang="en-US" sz="1550" dirty="0"/>
-          </a:p>
-          <a:p>
-            <a:pPr indent="0" marL="0">
+            <a:pPr marL="0" indent="0">
               <a:lnSpc>
                 <a:spcPts val="2100"/>
               </a:lnSpc>
@@ -14454,7 +14284,7 @@
           <a:bodyPr wrap="square" rtlCol="0" anchor="ctr"/>
           <a:lstStyle/>
           <a:p>
-            <a:pPr indent="0" marL="0">
+            <a:pPr marL="0" indent="0">
               <a:lnSpc>
                 <a:spcPts val="2000"/>
               </a:lnSpc>
@@ -14471,12 +14301,6 @@
               </a:rPr>
               <a:t>人类同款机制：</a:t>
             </a:r>
-            <a:pPr indent="0" marL="0">
-              <a:lnSpc>
-                <a:spcPts val="2000"/>
-              </a:lnSpc>
-              <a:buNone/>
-            </a:pPr>
             <a:r>
               <a:rPr lang="en-US" sz="1350" dirty="0">
                 <a:solidFill>
@@ -14535,7 +14359,7 @@
           <a:bodyPr wrap="square" rtlCol="0" anchor="ctr"/>
           <a:lstStyle/>
           <a:p>
-            <a:pPr indent="0" marL="0">
+            <a:pPr marL="0" indent="0">
               <a:lnSpc>
                 <a:spcPts val="1800"/>
               </a:lnSpc>
@@ -14553,12 +14377,6 @@
               <a:t>执行者 agent
 </a:t>
             </a:r>
-            <a:pPr indent="0" marL="0">
-              <a:lnSpc>
-                <a:spcPts val="1800"/>
-              </a:lnSpc>
-              <a:buNone/>
-            </a:pPr>
             <a:r>
               <a:rPr lang="en-US" sz="1150" dirty="0">
                 <a:solidFill>
@@ -14595,7 +14413,7 @@
           <a:bodyPr wrap="square" rtlCol="0" anchor="ctr"/>
           <a:lstStyle/>
           <a:p>
-            <a:pPr algn="ctr" indent="0" marL="0">
+            <a:pPr marL="0" indent="0" algn="ctr">
               <a:buNone/>
             </a:pPr>
             <a:r>
@@ -14656,7 +14474,7 @@
           <a:bodyPr wrap="square" rtlCol="0" anchor="ctr"/>
           <a:lstStyle/>
           <a:p>
-            <a:pPr indent="0" marL="0">
+            <a:pPr marL="0" indent="0">
               <a:lnSpc>
                 <a:spcPts val="1800"/>
               </a:lnSpc>
@@ -14674,55 +14492,49 @@
               <a:t>独立评判者
 </a:t>
             </a:r>
-            <a:pPr indent="0" marL="0">
+            <a:r>
+              <a:rPr lang="en-US" sz="1150" dirty="0">
+                <a:solidFill>
+                  <a:srgbClr val="FFFFFF"/>
+                </a:solidFill>
+                <a:latin typeface="Microsoft YaHei" pitchFamily="34" charset="0"/>
+                <a:ea typeface="Microsoft YaHei" pitchFamily="34" charset="-122"/>
+                <a:cs typeface="Microsoft YaHei" pitchFamily="34" charset="-120"/>
+              </a:rPr>
+              <a:t>另一个模型 / 子代理 / 测试套件，判定目标是否达成</a:t>
+            </a:r>
+            <a:endParaRPr lang="en-US" sz="1500" dirty="0"/>
+          </a:p>
+        </p:txBody>
+      </p:sp>
+      <p:sp>
+        <p:nvSpPr>
+          <p:cNvPr id="16" name="Text 14"/>
+          <p:cNvSpPr/>
+          <p:nvPr/>
+        </p:nvSpPr>
+        <p:spPr>
+          <a:xfrm>
+            <a:off x="6675120" y="5029200"/>
+            <a:ext cx="4937760" cy="1005840"/>
+          </a:xfrm>
+          <a:prstGeom prst="rect">
+            <a:avLst/>
+          </a:prstGeom>
+          <a:noFill/>
+          <a:ln/>
+        </p:spPr>
+        <p:txBody>
+          <a:bodyPr wrap="square" rtlCol="0" anchor="ctr"/>
+          <a:lstStyle/>
+          <a:p>
+            <a:pPr marL="0" indent="0">
               <a:lnSpc>
                 <a:spcPts val="1800"/>
               </a:lnSpc>
               <a:buNone/>
             </a:pPr>
             <a:r>
-              <a:rPr lang="en-US" sz="1150" dirty="0">
-                <a:solidFill>
-                  <a:srgbClr val="FFFFFF"/>
-                </a:solidFill>
-                <a:latin typeface="Microsoft YaHei" pitchFamily="34" charset="0"/>
-                <a:ea typeface="Microsoft YaHei" pitchFamily="34" charset="-122"/>
-                <a:cs typeface="Microsoft YaHei" pitchFamily="34" charset="-120"/>
-              </a:rPr>
-              <a:t>另一个模型 / 子代理 / 测试套件，判定目标是否达成</a:t>
-            </a:r>
-            <a:endParaRPr lang="en-US" sz="1500" dirty="0"/>
-          </a:p>
-        </p:txBody>
-      </p:sp>
-      <p:sp>
-        <p:nvSpPr>
-          <p:cNvPr id="16" name="Text 14"/>
-          <p:cNvSpPr/>
-          <p:nvPr/>
-        </p:nvSpPr>
-        <p:spPr>
-          <a:xfrm>
-            <a:off x="6675120" y="5029200"/>
-            <a:ext cx="4937760" cy="1005840"/>
-          </a:xfrm>
-          <a:prstGeom prst="rect">
-            <a:avLst/>
-          </a:prstGeom>
-          <a:noFill/>
-          <a:ln/>
-        </p:spPr>
-        <p:txBody>
-          <a:bodyPr wrap="square" rtlCol="0" anchor="ctr"/>
-          <a:lstStyle/>
-          <a:p>
-            <a:pPr indent="0" marL="0">
-              <a:lnSpc>
-                <a:spcPts val="1800"/>
-              </a:lnSpc>
-              <a:buNone/>
-            </a:pPr>
-            <a:r>
               <a:rPr lang="en-US" sz="1200" i="1" dirty="0">
                 <a:solidFill>
                   <a:srgbClr val="6B7280"/>
@@ -14758,7 +14570,7 @@
           <a:bodyPr wrap="square" rtlCol="0" anchor="ctr"/>
           <a:lstStyle/>
           <a:p>
-            <a:pPr indent="0" marL="0">
+            <a:pPr marL="0" indent="0">
               <a:buNone/>
             </a:pPr>
             <a:r>
@@ -14797,7 +14609,7 @@
           <a:bodyPr wrap="square" rtlCol="0" anchor="ctr"/>
           <a:lstStyle/>
           <a:p>
-            <a:pPr algn="r" indent="0" marL="0">
+            <a:pPr marL="0" indent="0" algn="r">
               <a:buNone/>
             </a:pPr>
             <a:r>
@@ -14831,6 +14643,7 @@
         <a:solidFill>
           <a:srgbClr val="FFFFFF"/>
         </a:solidFill>
+        <a:effectLst/>
       </p:bgPr>
     </p:bg>
     <p:spTree>
@@ -14868,11 +14681,11 @@
           <a:bodyPr wrap="square" rtlCol="0" anchor="ctr"/>
           <a:lstStyle/>
           <a:p>
-            <a:pPr indent="0" marL="0">
-              <a:buNone/>
-            </a:pPr>
-            <a:r>
-              <a:rPr lang="en-US" sz="1200" b="1" spc="200" kern="0" dirty="0">
+            <a:pPr marL="0" indent="0">
+              <a:buNone/>
+            </a:pPr>
+            <a:r>
+              <a:rPr lang="en-US" sz="1200" b="1" kern="0" spc="200" dirty="0">
                 <a:solidFill>
                   <a:srgbClr val="F96167"/>
                 </a:solidFill>
@@ -14907,7 +14720,7 @@
           <a:bodyPr wrap="square" rtlCol="0" anchor="ctr"/>
           <a:lstStyle/>
           <a:p>
-            <a:pPr indent="0" marL="0">
+            <a:pPr marL="0" indent="0">
               <a:buNone/>
             </a:pPr>
             <a:r>
@@ -15013,16 +14826,34 @@
         </p:nvGraphicFramePr>
         <p:xfrm>
           <a:off x="548640" y="1783080"/>
-          <a:ext cx="6035040" cy="914400"/>
+          <a:ext cx="6035040" cy="1901952"/>
         </p:xfrm>
         <a:graphic>
           <a:graphicData uri="http://schemas.openxmlformats.org/drawingml/2006/table">
             <a:tbl>
               <a:tblPr/>
               <a:tblGrid>
-                <a:gridCol w="1005840"/>
-                <a:gridCol w="2514600"/>
-                <a:gridCol w="2514600"/>
+                <a:gridCol w="1005840">
+                  <a:extLst>
+                    <a:ext uri="{9D8B030D-6E8A-4147-A177-3AD203B41FA5}">
+                      <a16:colId xmlns:a16="http://schemas.microsoft.com/office/drawing/2014/main" val="20000"/>
+                    </a:ext>
+                  </a:extLst>
+                </a:gridCol>
+                <a:gridCol w="2514600">
+                  <a:extLst>
+                    <a:ext uri="{9D8B030D-6E8A-4147-A177-3AD203B41FA5}">
+                      <a16:colId xmlns:a16="http://schemas.microsoft.com/office/drawing/2014/main" val="20001"/>
+                    </a:ext>
+                  </a:extLst>
+                </a:gridCol>
+                <a:gridCol w="2514600">
+                  <a:extLst>
+                    <a:ext uri="{9D8B030D-6E8A-4147-A177-3AD203B41FA5}">
+                      <a16:colId xmlns:a16="http://schemas.microsoft.com/office/drawing/2014/main" val="20002"/>
+                    </a:ext>
+                  </a:extLst>
+                </a:gridCol>
               </a:tblGrid>
               <a:tr h="475488">
                 <a:tc>
@@ -15030,7 +14861,7 @@
                     <a:bodyPr/>
                     <a:lstStyle/>
                     <a:p>
-                      <a:pPr indent="0" marL="0">
+                      <a:pPr marL="0" indent="0">
                         <a:buNone/>
                       </a:pPr>
                       <a:endParaRPr lang="en-US" sz="1150" dirty="0">
@@ -15040,7 +14871,7 @@
                       </a:endParaRPr>
                     </a:p>
                   </a:txBody>
-                  <a:tcPr marL="91440" marR="91440" marT="45720" marB="45720" anchor="ctr">
+                  <a:tcPr anchor="ctr">
                     <a:lnL w="12700" cap="flat" cmpd="sng" algn="ctr">
                       <a:solidFill>
                         <a:srgbClr val="D8E2F5"/>
@@ -15084,7 +14915,7 @@
                     <a:bodyPr/>
                     <a:lstStyle/>
                     <a:p>
-                      <a:pPr indent="0" marL="0">
+                      <a:pPr marL="0" indent="0">
                         <a:buNone/>
                       </a:pPr>
                       <a:r>
@@ -15105,7 +14936,7 @@
                       </a:endParaRPr>
                     </a:p>
                   </a:txBody>
-                  <a:tcPr marL="91440" marR="91440" marT="45720" marB="45720" anchor="ctr">
+                  <a:tcPr anchor="ctr">
                     <a:lnL w="12700" cap="flat" cmpd="sng" algn="ctr">
                       <a:solidFill>
                         <a:srgbClr val="D8E2F5"/>
@@ -15152,7 +14983,7 @@
                     <a:bodyPr/>
                     <a:lstStyle/>
                     <a:p>
-                      <a:pPr indent="0" marL="0">
+                      <a:pPr marL="0" indent="0">
                         <a:buNone/>
                       </a:pPr>
                       <a:r>
@@ -15173,7 +15004,7 @@
                       </a:endParaRPr>
                     </a:p>
                   </a:txBody>
-                  <a:tcPr marL="91440" marR="91440" marT="45720" marB="45720" anchor="ctr">
+                  <a:tcPr anchor="ctr">
                     <a:lnL w="12700" cap="flat" cmpd="sng" algn="ctr">
                       <a:solidFill>
                         <a:srgbClr val="D8E2F5"/>
@@ -15215,6 +15046,11 @@
                     </a:solidFill>
                   </a:tcPr>
                 </a:tc>
+                <a:extLst>
+                  <a:ext uri="{0D108BD9-81ED-4DB2-BD59-A6C34878D82A}">
+                    <a16:rowId xmlns:a16="http://schemas.microsoft.com/office/drawing/2014/main" val="10000"/>
+                  </a:ext>
+                </a:extLst>
               </a:tr>
               <a:tr h="475488">
                 <a:tc>
@@ -15222,7 +15058,7 @@
                     <a:bodyPr/>
                     <a:lstStyle/>
                     <a:p>
-                      <a:pPr indent="0" marL="0">
+                      <a:pPr marL="0" indent="0">
                         <a:buNone/>
                       </a:pPr>
                       <a:r>
@@ -15243,7 +15079,7 @@
                       </a:endParaRPr>
                     </a:p>
                   </a:txBody>
-                  <a:tcPr marL="91440" marR="91440" marT="45720" marB="45720" anchor="ctr">
+                  <a:tcPr anchor="ctr">
                     <a:lnL w="12700" cap="flat" cmpd="sng" algn="ctr">
                       <a:solidFill>
                         <a:srgbClr val="D8E2F5"/>
@@ -15290,7 +15126,7 @@
                     <a:bodyPr/>
                     <a:lstStyle/>
                     <a:p>
-                      <a:pPr indent="0" marL="0">
+                      <a:pPr marL="0" indent="0">
                         <a:buNone/>
                       </a:pPr>
                       <a:r>
@@ -15311,7 +15147,7 @@
                       </a:endParaRPr>
                     </a:p>
                   </a:txBody>
-                  <a:tcPr marL="91440" marR="91440" marT="45720" marB="45720" anchor="ctr">
+                  <a:tcPr anchor="ctr">
                     <a:lnL w="12700" cap="flat" cmpd="sng" algn="ctr">
                       <a:solidFill>
                         <a:srgbClr val="D8E2F5"/>
@@ -15358,7 +15194,7 @@
                     <a:bodyPr/>
                     <a:lstStyle/>
                     <a:p>
-                      <a:pPr indent="0" marL="0">
+                      <a:pPr marL="0" indent="0">
                         <a:buNone/>
                       </a:pPr>
                       <a:r>
@@ -15379,7 +15215,7 @@
                       </a:endParaRPr>
                     </a:p>
                   </a:txBody>
-                  <a:tcPr marL="91440" marR="91440" marT="45720" marB="45720" anchor="ctr">
+                  <a:tcPr anchor="ctr">
                     <a:lnL w="12700" cap="flat" cmpd="sng" algn="ctr">
                       <a:solidFill>
                         <a:srgbClr val="D8E2F5"/>
@@ -15421,6 +15257,11 @@
                     </a:solidFill>
                   </a:tcPr>
                 </a:tc>
+                <a:extLst>
+                  <a:ext uri="{0D108BD9-81ED-4DB2-BD59-A6C34878D82A}">
+                    <a16:rowId xmlns:a16="http://schemas.microsoft.com/office/drawing/2014/main" val="10001"/>
+                  </a:ext>
+                </a:extLst>
               </a:tr>
               <a:tr h="475488">
                 <a:tc>
@@ -15428,7 +15269,7 @@
                     <a:bodyPr/>
                     <a:lstStyle/>
                     <a:p>
-                      <a:pPr indent="0" marL="0">
+                      <a:pPr marL="0" indent="0">
                         <a:buNone/>
                       </a:pPr>
                       <a:r>
@@ -15449,7 +15290,7 @@
                       </a:endParaRPr>
                     </a:p>
                   </a:txBody>
-                  <a:tcPr marL="91440" marR="91440" marT="45720" marB="45720" anchor="ctr">
+                  <a:tcPr anchor="ctr">
                     <a:lnL w="12700" cap="flat" cmpd="sng" algn="ctr">
                       <a:solidFill>
                         <a:srgbClr val="D8E2F5"/>
@@ -15496,7 +15337,7 @@
                     <a:bodyPr/>
                     <a:lstStyle/>
                     <a:p>
-                      <a:pPr indent="0" marL="0">
+                      <a:pPr marL="0" indent="0">
                         <a:buNone/>
                       </a:pPr>
                       <a:r>
@@ -15517,7 +15358,7 @@
                       </a:endParaRPr>
                     </a:p>
                   </a:txBody>
-                  <a:tcPr marL="91440" marR="91440" marT="45720" marB="45720" anchor="ctr">
+                  <a:tcPr anchor="ctr">
                     <a:lnL w="12700" cap="flat" cmpd="sng" algn="ctr">
                       <a:solidFill>
                         <a:srgbClr val="D8E2F5"/>
@@ -15564,7 +15405,7 @@
                     <a:bodyPr/>
                     <a:lstStyle/>
                     <a:p>
-                      <a:pPr indent="0" marL="0">
+                      <a:pPr marL="0" indent="0">
                         <a:buNone/>
                       </a:pPr>
                       <a:r>
@@ -15585,7 +15426,7 @@
                       </a:endParaRPr>
                     </a:p>
                   </a:txBody>
-                  <a:tcPr marL="91440" marR="91440" marT="45720" marB="45720" anchor="ctr">
+                  <a:tcPr anchor="ctr">
                     <a:lnL w="12700" cap="flat" cmpd="sng" algn="ctr">
                       <a:solidFill>
                         <a:srgbClr val="D8E2F5"/>
@@ -15627,6 +15468,11 @@
                     </a:solidFill>
                   </a:tcPr>
                 </a:tc>
+                <a:extLst>
+                  <a:ext uri="{0D108BD9-81ED-4DB2-BD59-A6C34878D82A}">
+                    <a16:rowId xmlns:a16="http://schemas.microsoft.com/office/drawing/2014/main" val="10002"/>
+                  </a:ext>
+                </a:extLst>
               </a:tr>
               <a:tr h="475488">
                 <a:tc>
@@ -15634,7 +15480,7 @@
                     <a:bodyPr/>
                     <a:lstStyle/>
                     <a:p>
-                      <a:pPr indent="0" marL="0">
+                      <a:pPr marL="0" indent="0">
                         <a:buNone/>
                       </a:pPr>
                       <a:r>
@@ -15655,7 +15501,7 @@
                       </a:endParaRPr>
                     </a:p>
                   </a:txBody>
-                  <a:tcPr marL="91440" marR="91440" marT="45720" marB="45720" anchor="ctr">
+                  <a:tcPr anchor="ctr">
                     <a:lnL w="12700" cap="flat" cmpd="sng" algn="ctr">
                       <a:solidFill>
                         <a:srgbClr val="D8E2F5"/>
@@ -15702,7 +15548,7 @@
                     <a:bodyPr/>
                     <a:lstStyle/>
                     <a:p>
-                      <a:pPr indent="0" marL="0">
+                      <a:pPr marL="0" indent="0">
                         <a:buNone/>
                       </a:pPr>
                       <a:r>
@@ -15723,7 +15569,7 @@
                       </a:endParaRPr>
                     </a:p>
                   </a:txBody>
-                  <a:tcPr marL="91440" marR="91440" marT="45720" marB="45720" anchor="ctr">
+                  <a:tcPr anchor="ctr">
                     <a:lnL w="12700" cap="flat" cmpd="sng" algn="ctr">
                       <a:solidFill>
                         <a:srgbClr val="D8E2F5"/>
@@ -15770,7 +15616,7 @@
                     <a:bodyPr/>
                     <a:lstStyle/>
                     <a:p>
-                      <a:pPr indent="0" marL="0">
+                      <a:pPr marL="0" indent="0">
                         <a:buNone/>
                       </a:pPr>
                       <a:r>
@@ -15791,7 +15637,7 @@
                       </a:endParaRPr>
                     </a:p>
                   </a:txBody>
-                  <a:tcPr marL="91440" marR="91440" marT="45720" marB="45720" anchor="ctr">
+                  <a:tcPr anchor="ctr">
                     <a:lnL w="12700" cap="flat" cmpd="sng" algn="ctr">
                       <a:solidFill>
                         <a:srgbClr val="D8E2F5"/>
@@ -15833,6 +15679,11 @@
                     </a:solidFill>
                   </a:tcPr>
                 </a:tc>
+                <a:extLst>
+                  <a:ext uri="{0D108BD9-81ED-4DB2-BD59-A6C34878D82A}">
+                    <a16:rowId xmlns:a16="http://schemas.microsoft.com/office/drawing/2014/main" val="10003"/>
+                  </a:ext>
+                </a:extLst>
               </a:tr>
             </a:tbl>
           </a:graphicData>
@@ -15859,7 +15710,7 @@
           <a:bodyPr wrap="square" rtlCol="0" anchor="ctr"/>
           <a:lstStyle/>
           <a:p>
-            <a:pPr indent="0" marL="0">
+            <a:pPr marL="0" indent="0">
               <a:lnSpc>
                 <a:spcPts val="2200"/>
               </a:lnSpc>
@@ -15877,12 +15728,6 @@
               <a:t>每一轮的标准模式
 </a:t>
             </a:r>
-            <a:pPr indent="0" marL="0">
-              <a:lnSpc>
-                <a:spcPts val="2200"/>
-              </a:lnSpc>
-              <a:buNone/>
-            </a:pPr>
             <a:r>
               <a:rPr lang="en-US" sz="1600" b="1" dirty="0">
                 <a:solidFill>
@@ -15895,12 +15740,6 @@
               <a:t>读状态 → 做一个增量 → 写状态 → 退出
 </a:t>
             </a:r>
-            <a:pPr indent="0" marL="0">
-              <a:lnSpc>
-                <a:spcPts val="2200"/>
-              </a:lnSpc>
-              <a:buNone/>
-            </a:pPr>
             <a:r>
               <a:rPr lang="en-US" sz="1200" dirty="0">
                 <a:solidFill>
@@ -15918,7 +15757,7 @@
       </p:sp>
       <p:sp>
         <p:nvSpPr>
-          <p:cNvPr id="9" name="Shape 6"/>
+          <p:cNvPr id="7" name="Shape 6"/>
           <p:cNvSpPr/>
           <p:nvPr/>
         </p:nvSpPr>
@@ -15959,7 +15798,7 @@
           <a:bodyPr wrap="square" rtlCol="0" anchor="ctr"/>
           <a:lstStyle/>
           <a:p>
-            <a:pPr indent="0" marL="0">
+            <a:pPr marL="0" indent="0">
               <a:buNone/>
             </a:pPr>
             <a:r>
@@ -16018,7 +15857,7 @@
           <a:bodyPr wrap="square" rtlCol="0" anchor="ctr"/>
           <a:lstStyle/>
           <a:p>
-            <a:pPr indent="0" marL="0">
+            <a:pPr marL="0" indent="0">
               <a:lnSpc>
                 <a:spcPts val="1600"/>
               </a:lnSpc>
@@ -16035,13 +15874,80 @@
               </a:rPr>
               <a:t>目标与计划　</a:t>
             </a:r>
-            <a:pPr indent="0" marL="0">
+            <a:r>
+              <a:rPr lang="en-US" sz="1100" dirty="0">
+                <a:solidFill>
+                  <a:srgbClr val="CADCFC"/>
+                </a:solidFill>
+                <a:latin typeface="Microsoft YaHei" pitchFamily="34" charset="0"/>
+                <a:ea typeface="Microsoft YaHei" pitchFamily="34" charset="-122"/>
+                <a:cs typeface="Microsoft YaHei" pitchFamily="34" charset="-120"/>
+              </a:rPr>
+              <a:t>每轮回读重新锚定，防目标漂移</a:t>
+            </a:r>
+            <a:endParaRPr lang="en-US" sz="1250" dirty="0"/>
+          </a:p>
+        </p:txBody>
+      </p:sp>
+      <p:sp>
+        <p:nvSpPr>
+          <p:cNvPr id="13" name="Shape 10"/>
+          <p:cNvSpPr/>
+          <p:nvPr/>
+        </p:nvSpPr>
+        <p:spPr>
+          <a:xfrm>
+            <a:off x="7178040" y="3264408"/>
+            <a:ext cx="146304" cy="146304"/>
+          </a:xfrm>
+          <a:prstGeom prst="ellipse">
+            <a:avLst/>
+          </a:prstGeom>
+          <a:solidFill>
+            <a:srgbClr val="CADCFC"/>
+          </a:solidFill>
+          <a:ln/>
+        </p:spPr>
+      </p:sp>
+      <p:sp>
+        <p:nvSpPr>
+          <p:cNvPr id="14" name="Text 11"/>
+          <p:cNvSpPr/>
+          <p:nvPr/>
+        </p:nvSpPr>
+        <p:spPr>
+          <a:xfrm>
+            <a:off x="7424928" y="3108960"/>
+            <a:ext cx="4023360" cy="566928"/>
+          </a:xfrm>
+          <a:prstGeom prst="rect">
+            <a:avLst/>
+          </a:prstGeom>
+          <a:noFill/>
+          <a:ln/>
+        </p:spPr>
+        <p:txBody>
+          <a:bodyPr wrap="square" rtlCol="0" anchor="ctr"/>
+          <a:lstStyle/>
+          <a:p>
+            <a:pPr marL="0" indent="0">
               <a:lnSpc>
                 <a:spcPts val="1600"/>
               </a:lnSpc>
               <a:buNone/>
             </a:pPr>
             <a:r>
+              <a:rPr lang="en-US" sz="1250" b="1" dirty="0">
+                <a:solidFill>
+                  <a:srgbClr val="FFFFFF"/>
+                </a:solidFill>
+                <a:latin typeface="Microsoft YaHei" pitchFamily="34" charset="0"/>
+                <a:ea typeface="Microsoft YaHei" pitchFamily="34" charset="-122"/>
+                <a:cs typeface="Microsoft YaHei" pitchFamily="34" charset="-120"/>
+              </a:rPr>
+              <a:t>已完成清单　</a:t>
+            </a:r>
+            <a:r>
               <a:rPr lang="en-US" sz="1100" dirty="0">
                 <a:solidFill>
                   <a:srgbClr val="CADCFC"/>
@@ -16050,7 +15956,7 @@
                 <a:ea typeface="Microsoft YaHei" pitchFamily="34" charset="-122"/>
                 <a:cs typeface="Microsoft YaHei" pitchFamily="34" charset="-120"/>
               </a:rPr>
-              <a:t>每轮回读重新锚定，防目标漂移</a:t>
+              <a:t>防重复劳动</a:t>
             </a:r>
             <a:endParaRPr lang="en-US" sz="1250" dirty="0"/>
           </a:p>
@@ -16058,13 +15964,13 @@
       </p:sp>
       <p:sp>
         <p:nvSpPr>
-          <p:cNvPr id="13" name="Shape 10"/>
-          <p:cNvSpPr/>
-          <p:nvPr/>
-        </p:nvSpPr>
-        <p:spPr>
-          <a:xfrm>
-            <a:off x="7178040" y="3264408"/>
+          <p:cNvPr id="15" name="Shape 12"/>
+          <p:cNvSpPr/>
+          <p:nvPr/>
+        </p:nvSpPr>
+        <p:spPr>
+          <a:xfrm>
+            <a:off x="7178040" y="3941064"/>
             <a:ext cx="146304" cy="146304"/>
           </a:xfrm>
           <a:prstGeom prst="ellipse">
@@ -16078,13 +15984,13 @@
       </p:sp>
       <p:sp>
         <p:nvSpPr>
-          <p:cNvPr id="14" name="Text 11"/>
-          <p:cNvSpPr/>
-          <p:nvPr/>
-        </p:nvSpPr>
-        <p:spPr>
-          <a:xfrm>
-            <a:off x="7424928" y="3108960"/>
+          <p:cNvPr id="16" name="Text 13"/>
+          <p:cNvSpPr/>
+          <p:nvPr/>
+        </p:nvSpPr>
+        <p:spPr>
+          <a:xfrm>
+            <a:off x="7424928" y="3785616"/>
             <a:ext cx="4023360" cy="566928"/>
           </a:xfrm>
           <a:prstGeom prst="rect">
@@ -16097,7 +16003,7 @@
           <a:bodyPr wrap="square" rtlCol="0" anchor="ctr"/>
           <a:lstStyle/>
           <a:p>
-            <a:pPr indent="0" marL="0">
+            <a:pPr marL="0" indent="0">
               <a:lnSpc>
                 <a:spcPts val="1600"/>
               </a:lnSpc>
@@ -16112,15 +16018,82 @@
                 <a:ea typeface="Microsoft YaHei" pitchFamily="34" charset="-122"/>
                 <a:cs typeface="Microsoft YaHei" pitchFamily="34" charset="-120"/>
               </a:rPr>
-              <a:t>已完成清单　</a:t>
-            </a:r>
-            <a:pPr indent="0" marL="0">
+              <a:t>决策及理由　</a:t>
+            </a:r>
+            <a:r>
+              <a:rPr lang="en-US" sz="1100" dirty="0">
+                <a:solidFill>
+                  <a:srgbClr val="CADCFC"/>
+                </a:solidFill>
+                <a:latin typeface="Microsoft YaHei" pitchFamily="34" charset="0"/>
+                <a:ea typeface="Microsoft YaHei" pitchFamily="34" charset="-122"/>
+                <a:cs typeface="Microsoft YaHei" pitchFamily="34" charset="-120"/>
+              </a:rPr>
+              <a:t>防止后续轮次翻案</a:t>
+            </a:r>
+            <a:endParaRPr lang="en-US" sz="1250" dirty="0"/>
+          </a:p>
+        </p:txBody>
+      </p:sp>
+      <p:sp>
+        <p:nvSpPr>
+          <p:cNvPr id="17" name="Shape 14"/>
+          <p:cNvSpPr/>
+          <p:nvPr/>
+        </p:nvSpPr>
+        <p:spPr>
+          <a:xfrm>
+            <a:off x="7178040" y="4617720"/>
+            <a:ext cx="146304" cy="146304"/>
+          </a:xfrm>
+          <a:prstGeom prst="ellipse">
+            <a:avLst/>
+          </a:prstGeom>
+          <a:solidFill>
+            <a:srgbClr val="F96167"/>
+          </a:solidFill>
+          <a:ln/>
+        </p:spPr>
+      </p:sp>
+      <p:sp>
+        <p:nvSpPr>
+          <p:cNvPr id="18" name="Text 15"/>
+          <p:cNvSpPr/>
+          <p:nvPr/>
+        </p:nvSpPr>
+        <p:spPr>
+          <a:xfrm>
+            <a:off x="7424928" y="4462272"/>
+            <a:ext cx="4023360" cy="566928"/>
+          </a:xfrm>
+          <a:prstGeom prst="rect">
+            <a:avLst/>
+          </a:prstGeom>
+          <a:noFill/>
+          <a:ln/>
+        </p:spPr>
+        <p:txBody>
+          <a:bodyPr wrap="square" rtlCol="0" anchor="ctr"/>
+          <a:lstStyle/>
+          <a:p>
+            <a:pPr marL="0" indent="0">
               <a:lnSpc>
                 <a:spcPts val="1600"/>
               </a:lnSpc>
               <a:buNone/>
             </a:pPr>
             <a:r>
+              <a:rPr lang="en-US" sz="1250" b="1" dirty="0">
+                <a:solidFill>
+                  <a:srgbClr val="F96167"/>
+                </a:solidFill>
+                <a:latin typeface="Microsoft YaHei" pitchFamily="34" charset="0"/>
+                <a:ea typeface="Microsoft YaHei" pitchFamily="34" charset="-122"/>
+                <a:cs typeface="Microsoft YaHei" pitchFamily="34" charset="-120"/>
+              </a:rPr>
+              <a:t>失败尝试　</a:t>
+            </a:r>
+            <a:r>
               <a:rPr lang="en-US" sz="1100" dirty="0">
                 <a:solidFill>
                   <a:srgbClr val="CADCFC"/>
@@ -16129,7 +16102,7 @@
                 <a:ea typeface="Microsoft YaHei" pitchFamily="34" charset="-122"/>
                 <a:cs typeface="Microsoft YaHei" pitchFamily="34" charset="-120"/>
               </a:rPr>
-              <a:t>防重复劳动</a:t>
+              <a:t>付过钱的信息——不记就会反复撞同一堵墙</a:t>
             </a:r>
             <a:endParaRPr lang="en-US" sz="1250" dirty="0"/>
           </a:p>
@@ -16137,13 +16110,13 @@
       </p:sp>
       <p:sp>
         <p:nvSpPr>
-          <p:cNvPr id="15" name="Shape 12"/>
-          <p:cNvSpPr/>
-          <p:nvPr/>
-        </p:nvSpPr>
-        <p:spPr>
-          <a:xfrm>
-            <a:off x="7178040" y="3941064"/>
+          <p:cNvPr id="19" name="Shape 16"/>
+          <p:cNvSpPr/>
+          <p:nvPr/>
+        </p:nvSpPr>
+        <p:spPr>
+          <a:xfrm>
+            <a:off x="7178040" y="5294376"/>
             <a:ext cx="146304" cy="146304"/>
           </a:xfrm>
           <a:prstGeom prst="ellipse">
@@ -16157,13 +16130,13 @@
       </p:sp>
       <p:sp>
         <p:nvSpPr>
-          <p:cNvPr id="16" name="Text 13"/>
-          <p:cNvSpPr/>
-          <p:nvPr/>
-        </p:nvSpPr>
-        <p:spPr>
-          <a:xfrm>
-            <a:off x="7424928" y="3785616"/>
+          <p:cNvPr id="20" name="Text 17"/>
+          <p:cNvSpPr/>
+          <p:nvPr/>
+        </p:nvSpPr>
+        <p:spPr>
+          <a:xfrm>
+            <a:off x="7424928" y="5138928"/>
             <a:ext cx="4023360" cy="566928"/>
           </a:xfrm>
           <a:prstGeom prst="rect">
@@ -16176,7 +16149,7 @@
           <a:bodyPr wrap="square" rtlCol="0" anchor="ctr"/>
           <a:lstStyle/>
           <a:p>
-            <a:pPr indent="0" marL="0">
+            <a:pPr marL="0" indent="0">
               <a:lnSpc>
                 <a:spcPts val="1600"/>
               </a:lnSpc>
@@ -16191,172 +16164,8 @@
                 <a:ea typeface="Microsoft YaHei" pitchFamily="34" charset="-122"/>
                 <a:cs typeface="Microsoft YaHei" pitchFamily="34" charset="-120"/>
               </a:rPr>
-              <a:t>决策及理由　</a:t>
-            </a:r>
-            <a:pPr indent="0" marL="0">
-              <a:lnSpc>
-                <a:spcPts val="1600"/>
-              </a:lnSpc>
-              <a:buNone/>
-            </a:pPr>
-            <a:r>
-              <a:rPr lang="en-US" sz="1100" dirty="0">
-                <a:solidFill>
-                  <a:srgbClr val="CADCFC"/>
-                </a:solidFill>
-                <a:latin typeface="Microsoft YaHei" pitchFamily="34" charset="0"/>
-                <a:ea typeface="Microsoft YaHei" pitchFamily="34" charset="-122"/>
-                <a:cs typeface="Microsoft YaHei" pitchFamily="34" charset="-120"/>
-              </a:rPr>
-              <a:t>防止后续轮次翻案</a:t>
-            </a:r>
-            <a:endParaRPr lang="en-US" sz="1250" dirty="0"/>
-          </a:p>
-        </p:txBody>
-      </p:sp>
-      <p:sp>
-        <p:nvSpPr>
-          <p:cNvPr id="17" name="Shape 14"/>
-          <p:cNvSpPr/>
-          <p:nvPr/>
-        </p:nvSpPr>
-        <p:spPr>
-          <a:xfrm>
-            <a:off x="7178040" y="4617720"/>
-            <a:ext cx="146304" cy="146304"/>
-          </a:xfrm>
-          <a:prstGeom prst="ellipse">
-            <a:avLst/>
-          </a:prstGeom>
-          <a:solidFill>
-            <a:srgbClr val="F96167"/>
-          </a:solidFill>
-          <a:ln/>
-        </p:spPr>
-      </p:sp>
-      <p:sp>
-        <p:nvSpPr>
-          <p:cNvPr id="18" name="Text 15"/>
-          <p:cNvSpPr/>
-          <p:nvPr/>
-        </p:nvSpPr>
-        <p:spPr>
-          <a:xfrm>
-            <a:off x="7424928" y="4462272"/>
-            <a:ext cx="4023360" cy="566928"/>
-          </a:xfrm>
-          <a:prstGeom prst="rect">
-            <a:avLst/>
-          </a:prstGeom>
-          <a:noFill/>
-          <a:ln/>
-        </p:spPr>
-        <p:txBody>
-          <a:bodyPr wrap="square" rtlCol="0" anchor="ctr"/>
-          <a:lstStyle/>
-          <a:p>
-            <a:pPr indent="0" marL="0">
-              <a:lnSpc>
-                <a:spcPts val="1600"/>
-              </a:lnSpc>
-              <a:buNone/>
-            </a:pPr>
-            <a:r>
-              <a:rPr lang="en-US" sz="1250" b="1" dirty="0">
-                <a:solidFill>
-                  <a:srgbClr val="F96167"/>
-                </a:solidFill>
-                <a:latin typeface="Microsoft YaHei" pitchFamily="34" charset="0"/>
-                <a:ea typeface="Microsoft YaHei" pitchFamily="34" charset="-122"/>
-                <a:cs typeface="Microsoft YaHei" pitchFamily="34" charset="-120"/>
-              </a:rPr>
-              <a:t>失败尝试　</a:t>
-            </a:r>
-            <a:pPr indent="0" marL="0">
-              <a:lnSpc>
-                <a:spcPts val="1600"/>
-              </a:lnSpc>
-              <a:buNone/>
-            </a:pPr>
-            <a:r>
-              <a:rPr lang="en-US" sz="1100" dirty="0">
-                <a:solidFill>
-                  <a:srgbClr val="CADCFC"/>
-                </a:solidFill>
-                <a:latin typeface="Microsoft YaHei" pitchFamily="34" charset="0"/>
-                <a:ea typeface="Microsoft YaHei" pitchFamily="34" charset="-122"/>
-                <a:cs typeface="Microsoft YaHei" pitchFamily="34" charset="-120"/>
-              </a:rPr>
-              <a:t>付过钱的信息——不记就会反复撞同一堵墙</a:t>
-            </a:r>
-            <a:endParaRPr lang="en-US" sz="1250" dirty="0"/>
-          </a:p>
-        </p:txBody>
-      </p:sp>
-      <p:sp>
-        <p:nvSpPr>
-          <p:cNvPr id="19" name="Shape 16"/>
-          <p:cNvSpPr/>
-          <p:nvPr/>
-        </p:nvSpPr>
-        <p:spPr>
-          <a:xfrm>
-            <a:off x="7178040" y="5294376"/>
-            <a:ext cx="146304" cy="146304"/>
-          </a:xfrm>
-          <a:prstGeom prst="ellipse">
-            <a:avLst/>
-          </a:prstGeom>
-          <a:solidFill>
-            <a:srgbClr val="CADCFC"/>
-          </a:solidFill>
-          <a:ln/>
-        </p:spPr>
-      </p:sp>
-      <p:sp>
-        <p:nvSpPr>
-          <p:cNvPr id="20" name="Text 17"/>
-          <p:cNvSpPr/>
-          <p:nvPr/>
-        </p:nvSpPr>
-        <p:spPr>
-          <a:xfrm>
-            <a:off x="7424928" y="5138928"/>
-            <a:ext cx="4023360" cy="566928"/>
-          </a:xfrm>
-          <a:prstGeom prst="rect">
-            <a:avLst/>
-          </a:prstGeom>
-          <a:noFill/>
-          <a:ln/>
-        </p:spPr>
-        <p:txBody>
-          <a:bodyPr wrap="square" rtlCol="0" anchor="ctr"/>
-          <a:lstStyle/>
-          <a:p>
-            <a:pPr indent="0" marL="0">
-              <a:lnSpc>
-                <a:spcPts val="1600"/>
-              </a:lnSpc>
-              <a:buNone/>
-            </a:pPr>
-            <a:r>
-              <a:rPr lang="en-US" sz="1250" b="1" dirty="0">
-                <a:solidFill>
-                  <a:srgbClr val="FFFFFF"/>
-                </a:solidFill>
-                <a:latin typeface="Microsoft YaHei" pitchFamily="34" charset="0"/>
-                <a:ea typeface="Microsoft YaHei" pitchFamily="34" charset="-122"/>
-                <a:cs typeface="Microsoft YaHei" pitchFamily="34" charset="-120"/>
-              </a:rPr>
               <a:t>下一步指针　</a:t>
             </a:r>
-            <a:pPr indent="0" marL="0">
-              <a:lnSpc>
-                <a:spcPts val="1600"/>
-              </a:lnSpc>
-              <a:buNone/>
-            </a:pPr>
             <a:r>
               <a:rPr lang="en-US" sz="1100" dirty="0">
                 <a:solidFill>
@@ -16393,7 +16202,7 @@
           <a:bodyPr wrap="square" rtlCol="0" anchor="ctr"/>
           <a:lstStyle/>
           <a:p>
-            <a:pPr indent="0" marL="0">
+            <a:pPr marL="0" indent="0">
               <a:buNone/>
             </a:pPr>
             <a:r>
@@ -16432,7 +16241,7 @@
           <a:bodyPr wrap="square" rtlCol="0" anchor="ctr"/>
           <a:lstStyle/>
           <a:p>
-            <a:pPr algn="r" indent="0" marL="0">
+            <a:pPr marL="0" indent="0" algn="r">
               <a:buNone/>
             </a:pPr>
             <a:r>
@@ -16466,6 +16275,7 @@
         <a:solidFill>
           <a:srgbClr val="FFFFFF"/>
         </a:solidFill>
+        <a:effectLst/>
       </p:bgPr>
     </p:bg>
     <p:spTree>
@@ -16503,11 +16313,11 @@
           <a:bodyPr wrap="square" rtlCol="0" anchor="ctr"/>
           <a:lstStyle/>
           <a:p>
-            <a:pPr indent="0" marL="0">
-              <a:buNone/>
-            </a:pPr>
-            <a:r>
-              <a:rPr lang="en-US" sz="1200" b="1" spc="200" kern="0" dirty="0">
+            <a:pPr marL="0" indent="0">
+              <a:buNone/>
+            </a:pPr>
+            <a:r>
+              <a:rPr lang="en-US" sz="1200" b="1" kern="0" spc="200" dirty="0">
                 <a:solidFill>
                   <a:srgbClr val="F96167"/>
                 </a:solidFill>
@@ -16542,7 +16352,7 @@
           <a:bodyPr wrap="square" rtlCol="0" anchor="ctr"/>
           <a:lstStyle/>
           <a:p>
-            <a:pPr indent="0" marL="0">
+            <a:pPr marL="0" indent="0">
               <a:buNone/>
             </a:pPr>
             <a:r>
@@ -16680,7 +16490,7 @@
           <a:bodyPr wrap="square" rtlCol="0" anchor="ctr"/>
           <a:lstStyle/>
           <a:p>
-            <a:pPr indent="0" marL="0">
+            <a:pPr marL="0" indent="0">
               <a:buNone/>
             </a:pPr>
             <a:r>
@@ -16719,7 +16529,7 @@
           <a:bodyPr wrap="square" rtlCol="0" anchor="ctr"/>
           <a:lstStyle/>
           <a:p>
-            <a:pPr indent="0" marL="0">
+            <a:pPr marL="0" indent="0">
               <a:buNone/>
             </a:pPr>
             <a:r>
@@ -16758,7 +16568,7 @@
           <a:bodyPr wrap="square" rtlCol="0" anchor="ctr"/>
           <a:lstStyle/>
           <a:p>
-            <a:pPr indent="0" marL="0">
+            <a:pPr marL="0" indent="0">
               <a:lnSpc>
                 <a:spcPts val="1600"/>
               </a:lnSpc>
@@ -16827,7 +16637,7 @@
           <a:bodyPr wrap="square" rtlCol="0" anchor="ctr"/>
           <a:lstStyle/>
           <a:p>
-            <a:pPr indent="0" marL="0">
+            <a:pPr marL="0" indent="0">
               <a:buNone/>
             </a:pPr>
             <a:r>
@@ -16866,7 +16676,7 @@
           <a:bodyPr wrap="square" rtlCol="0" anchor="ctr"/>
           <a:lstStyle/>
           <a:p>
-            <a:pPr indent="0" marL="0">
+            <a:pPr marL="0" indent="0">
               <a:buNone/>
             </a:pPr>
             <a:r>
@@ -16905,7 +16715,7 @@
           <a:bodyPr wrap="square" rtlCol="0" anchor="ctr"/>
           <a:lstStyle/>
           <a:p>
-            <a:pPr indent="0" marL="0">
+            <a:pPr marL="0" indent="0">
               <a:lnSpc>
                 <a:spcPts val="1600"/>
               </a:lnSpc>
@@ -16974,7 +16784,7 @@
           <a:bodyPr wrap="square" rtlCol="0" anchor="ctr"/>
           <a:lstStyle/>
           <a:p>
-            <a:pPr indent="0" marL="0">
+            <a:pPr marL="0" indent="0">
               <a:buNone/>
             </a:pPr>
             <a:r>
@@ -17013,7 +16823,7 @@
           <a:bodyPr wrap="square" rtlCol="0" anchor="ctr"/>
           <a:lstStyle/>
           <a:p>
-            <a:pPr indent="0" marL="0">
+            <a:pPr marL="0" indent="0">
               <a:buNone/>
             </a:pPr>
             <a:r>
@@ -17052,7 +16862,7 @@
           <a:bodyPr wrap="square" rtlCol="0" anchor="ctr"/>
           <a:lstStyle/>
           <a:p>
-            <a:pPr indent="0" marL="0">
+            <a:pPr marL="0" indent="0">
               <a:lnSpc>
                 <a:spcPts val="1600"/>
               </a:lnSpc>
@@ -17121,7 +16931,7 @@
           <a:bodyPr wrap="square" rtlCol="0" anchor="ctr"/>
           <a:lstStyle/>
           <a:p>
-            <a:pPr indent="0" marL="0">
+            <a:pPr marL="0" indent="0">
               <a:buNone/>
             </a:pPr>
             <a:r>
@@ -17160,7 +16970,7 @@
           <a:bodyPr wrap="square" rtlCol="0" anchor="ctr"/>
           <a:lstStyle/>
           <a:p>
-            <a:pPr indent="0" marL="0">
+            <a:pPr marL="0" indent="0">
               <a:buNone/>
             </a:pPr>
             <a:r>
@@ -17199,7 +17009,7 @@
           <a:bodyPr wrap="square" rtlCol="0" anchor="ctr"/>
           <a:lstStyle/>
           <a:p>
-            <a:pPr indent="0" marL="0">
+            <a:pPr marL="0" indent="0">
               <a:lnSpc>
                 <a:spcPts val="1600"/>
               </a:lnSpc>
@@ -17268,7 +17078,7 @@
           <a:bodyPr wrap="square" rtlCol="0" anchor="ctr"/>
           <a:lstStyle/>
           <a:p>
-            <a:pPr indent="0" marL="0">
+            <a:pPr marL="0" indent="0">
               <a:buNone/>
             </a:pPr>
             <a:r>
@@ -17307,7 +17117,7 @@
           <a:bodyPr wrap="square" rtlCol="0" anchor="ctr"/>
           <a:lstStyle/>
           <a:p>
-            <a:pPr indent="0" marL="0">
+            <a:pPr marL="0" indent="0">
               <a:buNone/>
             </a:pPr>
             <a:r>
@@ -17346,7 +17156,7 @@
           <a:bodyPr wrap="square" rtlCol="0" anchor="ctr"/>
           <a:lstStyle/>
           <a:p>
-            <a:pPr indent="0" marL="0">
+            <a:pPr marL="0" indent="0">
               <a:lnSpc>
                 <a:spcPts val="1600"/>
               </a:lnSpc>
@@ -17410,7 +17220,7 @@
           <a:bodyPr wrap="square" rtlCol="0" anchor="ctr"/>
           <a:lstStyle/>
           <a:p>
-            <a:pPr indent="0" marL="0">
+            <a:pPr marL="0" indent="0">
               <a:buNone/>
             </a:pPr>
             <a:r>
@@ -17449,7 +17259,7 @@
           <a:bodyPr wrap="square" rtlCol="0" anchor="ctr"/>
           <a:lstStyle/>
           <a:p>
-            <a:pPr indent="0" marL="0">
+            <a:pPr marL="0" indent="0">
               <a:lnSpc>
                 <a:spcPts val="2200"/>
               </a:lnSpc>
@@ -17466,12 +17276,6 @@
               </a:rPr>
               <a:t>依赖别的团队？ </a:t>
             </a:r>
-            <a:pPr indent="0" marL="0">
-              <a:lnSpc>
-                <a:spcPts val="2200"/>
-              </a:lnSpc>
-              <a:buNone/>
-            </a:pPr>
             <a:r>
               <a:rPr lang="en-US" sz="1350" dirty="0">
                 <a:solidFill>
@@ -17484,12 +17288,6 @@
               <a:t>暂停等待对方 loop 修复的信号，收到再恢复验证。
 </a:t>
             </a:r>
-            <a:pPr indent="0" marL="0">
-              <a:lnSpc>
-                <a:spcPts val="2200"/>
-              </a:lnSpc>
-              <a:buNone/>
-            </a:pPr>
             <a:r>
               <a:rPr lang="en-US" sz="1350" b="1" dirty="0">
                 <a:solidFill>
@@ -17501,12 +17299,6 @@
               </a:rPr>
               <a:t>无进展空转？ </a:t>
             </a:r>
-            <a:pPr indent="0" marL="0">
-              <a:lnSpc>
-                <a:spcPts val="2200"/>
-              </a:lnSpc>
-              <a:buNone/>
-            </a:pPr>
             <a:r>
               <a:rPr lang="en-US" sz="1350" dirty="0">
                 <a:solidFill>
@@ -17543,7 +17335,7 @@
           <a:bodyPr wrap="square" rtlCol="0" anchor="ctr"/>
           <a:lstStyle/>
           <a:p>
-            <a:pPr indent="0" marL="0">
+            <a:pPr marL="0" indent="0">
               <a:buNone/>
             </a:pPr>
             <a:r>
@@ -17582,7 +17374,7 @@
           <a:bodyPr wrap="square" rtlCol="0" anchor="ctr"/>
           <a:lstStyle/>
           <a:p>
-            <a:pPr algn="r" indent="0" marL="0">
+            <a:pPr marL="0" indent="0" algn="r">
               <a:buNone/>
             </a:pPr>
             <a:r>
@@ -17901,4 +17693,299 @@
     </a:ext>
   </a:extLst>
 </a:theme>
+</file>
+
+<file path=ppt/theme/theme2.xml><?xml version="1.0" encoding="utf-8"?>
+<a:theme xmlns:a="http://schemas.openxmlformats.org/drawingml/2006/main" name="Office 主题​​">
+  <a:themeElements>
+    <a:clrScheme name="Office">
+      <a:dk1>
+        <a:sysClr val="windowText" lastClr="000000"/>
+      </a:dk1>
+      <a:lt1>
+        <a:sysClr val="window" lastClr="FFFFFF"/>
+      </a:lt1>
+      <a:dk2>
+        <a:srgbClr val="44546A"/>
+      </a:dk2>
+      <a:lt2>
+        <a:srgbClr val="E7E6E6"/>
+      </a:lt2>
+      <a:accent1>
+        <a:srgbClr val="4472C4"/>
+      </a:accent1>
+      <a:accent2>
+        <a:srgbClr val="ED7D31"/>
+      </a:accent2>
+      <a:accent3>
+        <a:srgbClr val="A5A5A5"/>
+      </a:accent3>
+      <a:accent4>
+        <a:srgbClr val="FFC000"/>
+      </a:accent4>
+      <a:accent5>
+        <a:srgbClr val="5B9BD5"/>
+      </a:accent5>
+      <a:accent6>
+        <a:srgbClr val="70AD47"/>
+      </a:accent6>
+      <a:hlink>
+        <a:srgbClr val="0563C1"/>
+      </a:hlink>
+      <a:folHlink>
+        <a:srgbClr val="954F72"/>
+      </a:folHlink>
+    </a:clrScheme>
+    <a:fontScheme name="Office">
+      <a:majorFont>
+        <a:latin typeface="等线 Light" panose="020F0302020204030204"/>
+        <a:ea typeface=""/>
+        <a:cs typeface=""/>
+        <a:font script="Jpan" typeface="游ゴシック Light"/>
+        <a:font script="Hang" typeface="맑은 고딕"/>
+        <a:font script="Hans" typeface="等线 Light"/>
+        <a:font script="Hant" typeface="新細明體"/>
+        <a:font script="Arab" typeface="Times New Roman"/>
+        <a:font script="Hebr" typeface="Times New Roman"/>
+        <a:font script="Thai" typeface="Angsana New"/>
+        <a:font script="Ethi" typeface="Nyala"/>
+        <a:font script="Beng" typeface="Vrinda"/>
+        <a:font script="Gujr" typeface="Shruti"/>
+        <a:font script="Khmr" typeface="MoolBoran"/>
+        <a:font script="Knda" typeface="Tunga"/>
+        <a:font script="Guru" typeface="Raavi"/>
+        <a:font script="Cans" typeface="Euphemia"/>
+        <a:font script="Cher" typeface="Plantagenet Cherokee"/>
+        <a:font script="Yiii" typeface="Microsoft Yi Baiti"/>
+        <a:font script="Tibt" typeface="Microsoft Himalaya"/>
+        <a:font script="Thaa" typeface="MV Boli"/>
+        <a:font script="Deva" typeface="Mangal"/>
+        <a:font script="Telu" typeface="Gautami"/>
+        <a:font script="Taml" typeface="Latha"/>
+        <a:font script="Syrc" typeface="Estrangelo Edessa"/>
+        <a:font script="Orya" typeface="Kalinga"/>
+        <a:font script="Mlym" typeface="Kartika"/>
+        <a:font script="Laoo" typeface="DokChampa"/>
+        <a:font script="Sinh" typeface="Iskoola Pota"/>
+        <a:font script="Mong" typeface="Mongolian Baiti"/>
+        <a:font script="Viet" typeface="Times New Roman"/>
+        <a:font script="Uigh" typeface="Microsoft Uighur"/>
+        <a:font script="Geor" typeface="Sylfaen"/>
+        <a:font script="Armn" typeface="Arial"/>
+        <a:font script="Bugi" typeface="Leelawadee UI"/>
+        <a:font script="Bopo" typeface="Microsoft JhengHei"/>
+        <a:font script="Java" typeface="Javanese Text"/>
+        <a:font script="Lisu" typeface="Segoe UI"/>
+        <a:font script="Mymr" typeface="Myanmar Text"/>
+        <a:font script="Nkoo" typeface="Ebrima"/>
+        <a:font script="Olck" typeface="Nirmala UI"/>
+        <a:font script="Osma" typeface="Ebrima"/>
+        <a:font script="Phag" typeface="Phagspa"/>
+        <a:font script="Syrn" typeface="Estrangelo Edessa"/>
+        <a:font script="Syrj" typeface="Estrangelo Edessa"/>
+        <a:font script="Syre" typeface="Estrangelo Edessa"/>
+        <a:font script="Sora" typeface="Nirmala UI"/>
+        <a:font script="Tale" typeface="Microsoft Tai Le"/>
+        <a:font script="Talu" typeface="Microsoft New Tai Lue"/>
+        <a:font script="Tfng" typeface="Ebrima"/>
+      </a:majorFont>
+      <a:minorFont>
+        <a:latin typeface="等线" panose="020F0502020204030204"/>
+        <a:ea typeface=""/>
+        <a:cs typeface=""/>
+        <a:font script="Jpan" typeface="游ゴシック"/>
+        <a:font script="Hang" typeface="맑은 고딕"/>
+        <a:font script="Hans" typeface="等线"/>
+        <a:font script="Hant" typeface="新細明體"/>
+        <a:font script="Arab" typeface="Arial"/>
+        <a:font script="Hebr" typeface="Arial"/>
+        <a:font script="Thai" typeface="Cordia New"/>
+        <a:font script="Ethi" typeface="Nyala"/>
+        <a:font script="Beng" typeface="Vrinda"/>
+        <a:font script="Gujr" typeface="Shruti"/>
+        <a:font script="Khmr" typeface="DaunPenh"/>
+        <a:font script="Knda" typeface="Tunga"/>
+        <a:font script="Guru" typeface="Raavi"/>
+        <a:font script="Cans" typeface="Euphemia"/>
+        <a:font script="Cher" typeface="Plantagenet Cherokee"/>
+        <a:font script="Yiii" typeface="Microsoft Yi Baiti"/>
+        <a:font script="Tibt" typeface="Microsoft Himalaya"/>
+        <a:font script="Thaa" typeface="MV Boli"/>
+        <a:font script="Deva" typeface="Mangal"/>
+        <a:font script="Telu" typeface="Gautami"/>
+        <a:font script="Taml" typeface="Latha"/>
+        <a:font script="Syrc" typeface="Estrangelo Edessa"/>
+        <a:font script="Orya" typeface="Kalinga"/>
+        <a:font script="Mlym" typeface="Kartika"/>
+        <a:font script="Laoo" typeface="DokChampa"/>
+        <a:font script="Sinh" typeface="Iskoola Pota"/>
+        <a:font script="Mong" typeface="Mongolian Baiti"/>
+        <a:font script="Viet" typeface="Arial"/>
+        <a:font script="Uigh" typeface="Microsoft Uighur"/>
+        <a:font script="Geor" typeface="Sylfaen"/>
+        <a:font script="Armn" typeface="Arial"/>
+        <a:font script="Bugi" typeface="Leelawadee UI"/>
+        <a:font script="Bopo" typeface="Microsoft JhengHei"/>
+        <a:font script="Java" typeface="Javanese Text"/>
+        <a:font script="Lisu" typeface="Segoe UI"/>
+        <a:font script="Mymr" typeface="Myanmar Text"/>
+        <a:font script="Nkoo" typeface="Ebrima"/>
+        <a:font script="Olck" typeface="Nirmala UI"/>
+        <a:font script="Osma" typeface="Ebrima"/>
+        <a:font script="Phag" typeface="Phagspa"/>
+        <a:font script="Syrn" typeface="Estrangelo Edessa"/>
+        <a:font script="Syrj" typeface="Estrangelo Edessa"/>
+        <a:font script="Syre" typeface="Estrangelo Edessa"/>
+        <a:font script="Sora" typeface="Nirmala UI"/>
+        <a:font script="Tale" typeface="Microsoft Tai Le"/>
+        <a:font script="Talu" typeface="Microsoft New Tai Lue"/>
+        <a:font script="Tfng" typeface="Ebrima"/>
+      </a:minorFont>
+    </a:fontScheme>
+    <a:fmtScheme name="Office">
+      <a:fillStyleLst>
+        <a:solidFill>
+          <a:schemeClr val="phClr"/>
+        </a:solidFill>
+        <a:gradFill rotWithShape="1">
+          <a:gsLst>
+            <a:gs pos="0">
+              <a:schemeClr val="phClr">
+                <a:lumMod val="110000"/>
+                <a:satMod val="105000"/>
+                <a:tint val="67000"/>
+              </a:schemeClr>
+            </a:gs>
+            <a:gs pos="50000">
+              <a:schemeClr val="phClr">
+                <a:lumMod val="105000"/>
+                <a:satMod val="103000"/>
+                <a:tint val="73000"/>
+              </a:schemeClr>
+            </a:gs>
+            <a:gs pos="100000">
+              <a:schemeClr val="phClr">
+                <a:lumMod val="105000"/>
+                <a:satMod val="109000"/>
+                <a:tint val="81000"/>
+              </a:schemeClr>
+            </a:gs>
+          </a:gsLst>
+          <a:lin ang="5400000" scaled="0"/>
+        </a:gradFill>
+        <a:gradFill rotWithShape="1">
+          <a:gsLst>
+            <a:gs pos="0">
+              <a:schemeClr val="phClr">
+                <a:satMod val="103000"/>
+                <a:lumMod val="102000"/>
+                <a:tint val="94000"/>
+              </a:schemeClr>
+            </a:gs>
+            <a:gs pos="50000">
+              <a:schemeClr val="phClr">
+                <a:satMod val="110000"/>
+                <a:lumMod val="100000"/>
+                <a:shade val="100000"/>
+              </a:schemeClr>
+            </a:gs>
+            <a:gs pos="100000">
+              <a:schemeClr val="phClr">
+                <a:lumMod val="99000"/>
+                <a:satMod val="120000"/>
+                <a:shade val="78000"/>
+              </a:schemeClr>
+            </a:gs>
+          </a:gsLst>
+          <a:lin ang="5400000" scaled="0"/>
+        </a:gradFill>
+      </a:fillStyleLst>
+      <a:lnStyleLst>
+        <a:ln w="6350" cap="flat" cmpd="sng" algn="ctr">
+          <a:solidFill>
+            <a:schemeClr val="phClr"/>
+          </a:solidFill>
+          <a:prstDash val="solid"/>
+          <a:miter lim="800000"/>
+        </a:ln>
+        <a:ln w="12700" cap="flat" cmpd="sng" algn="ctr">
+          <a:solidFill>
+            <a:schemeClr val="phClr"/>
+          </a:solidFill>
+          <a:prstDash val="solid"/>
+          <a:miter lim="800000"/>
+        </a:ln>
+        <a:ln w="19050" cap="flat" cmpd="sng" algn="ctr">
+          <a:solidFill>
+            <a:schemeClr val="phClr"/>
+          </a:solidFill>
+          <a:prstDash val="solid"/>
+          <a:miter lim="800000"/>
+        </a:ln>
+      </a:lnStyleLst>
+      <a:effectStyleLst>
+        <a:effectStyle>
+          <a:effectLst/>
+        </a:effectStyle>
+        <a:effectStyle>
+          <a:effectLst/>
+        </a:effectStyle>
+        <a:effectStyle>
+          <a:effectLst>
+            <a:outerShdw blurRad="57150" dist="19050" dir="5400000" algn="ctr" rotWithShape="0">
+              <a:srgbClr val="000000">
+                <a:alpha val="63000"/>
+              </a:srgbClr>
+            </a:outerShdw>
+          </a:effectLst>
+        </a:effectStyle>
+      </a:effectStyleLst>
+      <a:bgFillStyleLst>
+        <a:solidFill>
+          <a:schemeClr val="phClr"/>
+        </a:solidFill>
+        <a:solidFill>
+          <a:schemeClr val="phClr">
+            <a:tint val="95000"/>
+            <a:satMod val="170000"/>
+          </a:schemeClr>
+        </a:solidFill>
+        <a:gradFill rotWithShape="1">
+          <a:gsLst>
+            <a:gs pos="0">
+              <a:schemeClr val="phClr">
+                <a:tint val="93000"/>
+                <a:satMod val="150000"/>
+                <a:shade val="98000"/>
+                <a:lumMod val="102000"/>
+              </a:schemeClr>
+            </a:gs>
+            <a:gs pos="50000">
+              <a:schemeClr val="phClr">
+                <a:tint val="98000"/>
+                <a:satMod val="130000"/>
+                <a:shade val="90000"/>
+                <a:lumMod val="103000"/>
+              </a:schemeClr>
+            </a:gs>
+            <a:gs pos="100000">
+              <a:schemeClr val="phClr">
+                <a:shade val="63000"/>
+                <a:satMod val="120000"/>
+              </a:schemeClr>
+            </a:gs>
+          </a:gsLst>
+          <a:lin ang="5400000" scaled="0"/>
+        </a:gradFill>
+      </a:bgFillStyleLst>
+    </a:fmtScheme>
+  </a:themeElements>
+  <a:objectDefaults/>
+  <a:extraClrSchemeLst/>
+  <a:extLst>
+    <a:ext uri="{05A4C25C-085E-4340-85A3-A5531E510DB2}">
+      <thm15:themeFamily xmlns:thm15="http://schemas.microsoft.com/office/thememl/2012/main" name="Office Theme" id="{62F939B6-93AF-4DB8-9C6B-D6C7DFDC589F}" vid="{4A3C46E8-61CC-4603-A589-7422A47A8E4A}"/>
+    </a:ext>
+  </a:extLst>
+</a:theme>
 </file>
</xml_diff>